<commit_message>
Submission deck: fix the measuring cards and results scatter
Size question chips to one line like Manim's fit(), and draw the scatter
with the HTML's own point labels and sides instead of the fact-table marks.
</commit_message>
<xml_diff>
--- a/deliverables/04_presentation/Bayan_Submission.pptx
+++ b/deliverables/04_presentation/Bayan_Submission.pptx
@@ -12576,11 +12576,11 @@
         <p:spPr>
           <a:xfrm>
             <a:off x="2075688" y="5513832"/>
-            <a:ext cx="1375155" cy="325120"/>
+            <a:ext cx="1375155" cy="330708"/>
           </a:xfrm>
           <a:prstGeom prst="roundRect">
             <a:avLst>
-              <a:gd name="adj" fmla="val 25312"/>
+              <a:gd name="adj" fmla="val 24884"/>
             </a:avLst>
           </a:prstGeom>
           <a:solidFill>
@@ -12635,11 +12635,11 @@
         <p:spPr>
           <a:xfrm>
             <a:off x="3661155" y="5513832"/>
-            <a:ext cx="2026158" cy="325120"/>
+            <a:ext cx="2026158" cy="330708"/>
           </a:xfrm>
           <a:prstGeom prst="roundRect">
             <a:avLst>
-              <a:gd name="adj" fmla="val 25312"/>
+              <a:gd name="adj" fmla="val 24884"/>
             </a:avLst>
           </a:prstGeom>
           <a:solidFill>
@@ -12694,11 +12694,11 @@
         <p:spPr>
           <a:xfrm>
             <a:off x="5897626" y="5513832"/>
-            <a:ext cx="1552574" cy="325120"/>
+            <a:ext cx="1552574" cy="330708"/>
           </a:xfrm>
           <a:prstGeom prst="roundRect">
             <a:avLst>
-              <a:gd name="adj" fmla="val 25312"/>
+              <a:gd name="adj" fmla="val 24884"/>
             </a:avLst>
           </a:prstGeom>
           <a:solidFill>
@@ -14469,12 +14469,12 @@
         </p:nvSpPr>
         <p:spPr>
           <a:xfrm>
-            <a:off x="1112520" y="1600200"/>
-            <a:ext cx="1981199" cy="357631"/>
+            <a:off x="909828" y="1675637"/>
+            <a:ext cx="2212848" cy="397764"/>
           </a:xfrm>
           <a:prstGeom prst="roundRect">
             <a:avLst>
-              <a:gd name="adj" fmla="val 23011"/>
+              <a:gd name="adj" fmla="val 20689"/>
             </a:avLst>
           </a:prstGeom>
           <a:solidFill>
@@ -14507,7 +14507,7 @@
           <a:p>
             <a:pPr algn="ctr"/>
             <a:r>
-              <a:rPr sz="1300" b="0">
+              <a:rPr sz="1500" b="0">
                 <a:solidFill>
                   <a:srgbClr val="4A4842"/>
                 </a:solidFill>
@@ -14528,12 +14528,12 @@
         </p:nvSpPr>
         <p:spPr>
           <a:xfrm>
-            <a:off x="3520440" y="1508760"/>
-            <a:ext cx="2514600" cy="960120"/>
+            <a:off x="3625596" y="1440179"/>
+            <a:ext cx="2651760" cy="868680"/>
           </a:xfrm>
           <a:prstGeom prst="roundRect">
             <a:avLst>
-              <a:gd name="adj" fmla="val 9523"/>
+              <a:gd name="adj" fmla="val 12631"/>
             </a:avLst>
           </a:prstGeom>
           <a:solidFill>
@@ -14576,8 +14576,8 @@
         </p:nvSpPr>
         <p:spPr>
           <a:xfrm>
-            <a:off x="3520440" y="1627632"/>
-            <a:ext cx="2514600" cy="320040"/>
+            <a:off x="3625596" y="1568195"/>
+            <a:ext cx="2651760" cy="310896"/>
           </a:xfrm>
           <a:prstGeom prst="rect">
             <a:avLst/>
@@ -14592,7 +14592,7 @@
           <a:p>
             <a:pPr algn="ctr"/>
             <a:r>
-              <a:rPr sz="1600" b="1">
+              <a:rPr sz="1800" b="1">
                 <a:solidFill>
                   <a:srgbClr val="8A5E35"/>
                 </a:solidFill>
@@ -14613,8 +14613,8 @@
         </p:nvSpPr>
         <p:spPr>
           <a:xfrm>
-            <a:off x="3520440" y="1993392"/>
-            <a:ext cx="2514600" cy="256032"/>
+            <a:off x="3625596" y="1915667"/>
+            <a:ext cx="2651760" cy="256032"/>
           </a:xfrm>
           <a:prstGeom prst="rect">
             <a:avLst/>
@@ -14650,12 +14650,12 @@
         </p:nvSpPr>
         <p:spPr>
           <a:xfrm>
-            <a:off x="6797802" y="1600200"/>
-            <a:ext cx="2040636" cy="357631"/>
+            <a:off x="6780275" y="1675637"/>
+            <a:ext cx="3277743" cy="397764"/>
           </a:xfrm>
           <a:prstGeom prst="roundRect">
             <a:avLst>
-              <a:gd name="adj" fmla="val 23011"/>
+              <a:gd name="adj" fmla="val 20689"/>
             </a:avLst>
           </a:prstGeom>
           <a:solidFill>
@@ -14688,7 +14688,7 @@
           <a:p>
             <a:pPr algn="ctr"/>
             <a:r>
-              <a:rPr sz="1300" b="0">
+              <a:rPr sz="1500" b="0">
                 <a:solidFill>
                   <a:srgbClr val="4A4842"/>
                 </a:solidFill>
@@ -14696,7 +14696,7 @@
                 <a:cs typeface="Readex Pro"/>
                 <a:ea typeface="Readex Pro"/>
               </a:rPr>
-              <a:t>7 yes/no → P(yes)</a:t>
+              <a:t>7 yes/no questions → P(yes)</a:t>
             </a:r>
           </a:p>
         </p:txBody>
@@ -14709,8 +14709,8 @@
         </p:nvCxnSpPr>
         <p:spPr>
           <a:xfrm>
-            <a:off x="3063240" y="2011680"/>
-            <a:ext cx="411480" cy="0"/>
+            <a:off x="3195828" y="1874519"/>
+            <a:ext cx="356616" cy="0"/>
           </a:xfrm>
           <a:prstGeom prst="line">
             <a:avLst/>
@@ -14745,8 +14745,8 @@
         </p:nvCxnSpPr>
         <p:spPr>
           <a:xfrm>
-            <a:off x="6080760" y="2011680"/>
-            <a:ext cx="457200" cy="0"/>
+            <a:off x="6350508" y="1874519"/>
+            <a:ext cx="356615" cy="0"/>
           </a:xfrm>
           <a:prstGeom prst="line">
             <a:avLst/>
@@ -14781,12 +14781,12 @@
         </p:nvSpPr>
         <p:spPr>
           <a:xfrm>
-            <a:off x="566928" y="2880360"/>
-            <a:ext cx="4434840" cy="2606040"/>
+            <a:off x="566928" y="2926080"/>
+            <a:ext cx="4434840" cy="3063240"/>
           </a:xfrm>
           <a:prstGeom prst="roundRect">
             <a:avLst>
-              <a:gd name="adj" fmla="val 5614"/>
+              <a:gd name="adj" fmla="val 4776"/>
             </a:avLst>
           </a:prstGeom>
           <a:solidFill>
@@ -14829,8 +14829,8 @@
         </p:nvSpPr>
         <p:spPr>
           <a:xfrm>
-            <a:off x="566928" y="3035808"/>
-            <a:ext cx="4434840" cy="320040"/>
+            <a:off x="566928" y="3090672"/>
+            <a:ext cx="4434840" cy="347472"/>
           </a:xfrm>
           <a:prstGeom prst="rect">
             <a:avLst/>
@@ -14845,7 +14845,7 @@
           <a:p>
             <a:pPr algn="ctr"/>
             <a:r>
-              <a:rPr sz="1500" b="1">
+              <a:rPr sz="1600" b="1">
                 <a:solidFill>
                   <a:srgbClr val="8A5E35"/>
                 </a:solidFill>
@@ -14866,12 +14866,12 @@
         </p:nvSpPr>
         <p:spPr>
           <a:xfrm>
-            <a:off x="1297146" y="3520440"/>
-            <a:ext cx="2974403" cy="520192"/>
+            <a:off x="795528" y="3584448"/>
+            <a:ext cx="3977639" cy="442468"/>
           </a:xfrm>
           <a:prstGeom prst="roundRect">
             <a:avLst>
-              <a:gd name="adj" fmla="val 15820"/>
+              <a:gd name="adj" fmla="val 18599"/>
             </a:avLst>
           </a:prstGeom>
           <a:solidFill>
@@ -14904,7 +14904,7 @@
           <a:p>
             <a:pPr algn="ctr"/>
             <a:r>
-              <a:rPr sz="1150" b="1">
+              <a:rPr sz="1000" b="1">
                 <a:solidFill>
                   <a:srgbClr val="1A1A14"/>
                 </a:solidFill>
@@ -14912,21 +14912,7 @@
                 <a:cs typeface="Readex Pro"/>
                 <a:ea typeface="Readex Pro"/>
               </a:rPr>
-              <a:t>same meaning?  kept = yes ≥ 0.5</a:t>
-            </a:r>
-          </a:p>
-          <a:p>
-            <a:pPr algn="ctr"/>
-            <a:r>
-              <a:rPr sz="1150" b="1">
-                <a:solidFill>
-                  <a:srgbClr val="1A1A14"/>
-                </a:solidFill>
-                <a:latin typeface="Readex Pro"/>
-                <a:cs typeface="Readex Pro"/>
-                <a:ea typeface="Readex Pro"/>
-              </a:rPr>
-              <a:t>and every number kept</a:t>
+              <a:t>same meaning?  kept = yes ≥ 0.5 and every number kept</a:t>
             </a:r>
           </a:p>
         </p:txBody>
@@ -14939,12 +14925,12 @@
         </p:nvSpPr>
         <p:spPr>
           <a:xfrm>
-            <a:off x="2064639" y="3904488"/>
-            <a:ext cx="1439417" cy="333248"/>
+            <a:off x="1988058" y="4173220"/>
+            <a:ext cx="1592579" cy="514858"/>
           </a:xfrm>
           <a:prstGeom prst="roundRect">
             <a:avLst>
-              <a:gd name="adj" fmla="val 24695"/>
+              <a:gd name="adj" fmla="val 15984"/>
             </a:avLst>
           </a:prstGeom>
           <a:solidFill>
@@ -14977,7 +14963,7 @@
           <a:p>
             <a:pPr algn="ctr"/>
             <a:r>
-              <a:rPr sz="1150" b="0">
+              <a:rPr sz="1300" b="0">
                 <a:solidFill>
                   <a:srgbClr val="4A4842"/>
                 </a:solidFill>
@@ -14998,12 +14984,12 @@
         </p:nvSpPr>
         <p:spPr>
           <a:xfrm>
-            <a:off x="2024475" y="4288536"/>
-            <a:ext cx="1519745" cy="333248"/>
+            <a:off x="1942655" y="4834382"/>
+            <a:ext cx="1683384" cy="514858"/>
           </a:xfrm>
           <a:prstGeom prst="roundRect">
             <a:avLst>
-              <a:gd name="adj" fmla="val 24695"/>
+              <a:gd name="adj" fmla="val 15984"/>
             </a:avLst>
           </a:prstGeom>
           <a:solidFill>
@@ -15036,7 +15022,7 @@
           <a:p>
             <a:pPr algn="ctr"/>
             <a:r>
-              <a:rPr sz="1150" b="0">
+              <a:rPr sz="1300" b="0">
                 <a:solidFill>
                   <a:srgbClr val="4A4842"/>
                 </a:solidFill>
@@ -15057,12 +15043,12 @@
         </p:nvSpPr>
         <p:spPr>
           <a:xfrm>
-            <a:off x="2084355" y="4672584"/>
-            <a:ext cx="1399984" cy="333248"/>
+            <a:off x="2010346" y="5495544"/>
+            <a:ext cx="1548003" cy="514858"/>
           </a:xfrm>
           <a:prstGeom prst="roundRect">
             <a:avLst>
-              <a:gd name="adj" fmla="val 24695"/>
+              <a:gd name="adj" fmla="val 15984"/>
             </a:avLst>
           </a:prstGeom>
           <a:solidFill>
@@ -15095,7 +15081,7 @@
           <a:p>
             <a:pPr algn="ctr"/>
             <a:r>
-              <a:rPr sz="1150" b="0">
+              <a:rPr sz="1300" b="0">
                 <a:solidFill>
                   <a:srgbClr val="4A4842"/>
                 </a:solidFill>
@@ -15116,12 +15102,12 @@
         </p:nvSpPr>
         <p:spPr>
           <a:xfrm>
-            <a:off x="5321807" y="2880360"/>
-            <a:ext cx="4434840" cy="2606040"/>
+            <a:off x="5321807" y="2926080"/>
+            <a:ext cx="4434840" cy="3063240"/>
           </a:xfrm>
           <a:prstGeom prst="roundRect">
             <a:avLst>
-              <a:gd name="adj" fmla="val 5614"/>
+              <a:gd name="adj" fmla="val 4776"/>
             </a:avLst>
           </a:prstGeom>
           <a:solidFill>
@@ -15164,8 +15150,8 @@
         </p:nvSpPr>
         <p:spPr>
           <a:xfrm>
-            <a:off x="5321807" y="3035808"/>
-            <a:ext cx="4434840" cy="320040"/>
+            <a:off x="5321807" y="3090672"/>
+            <a:ext cx="4434840" cy="347472"/>
           </a:xfrm>
           <a:prstGeom prst="rect">
             <a:avLst/>
@@ -15180,7 +15166,7 @@
           <a:p>
             <a:pPr algn="ctr"/>
             <a:r>
-              <a:rPr sz="1500" b="1">
+              <a:rPr sz="1600" b="1">
                 <a:solidFill>
                   <a:srgbClr val="8A5E35"/>
                 </a:solidFill>
@@ -15201,12 +15187,12 @@
         </p:nvSpPr>
         <p:spPr>
           <a:xfrm>
-            <a:off x="6709251" y="3520440"/>
-            <a:ext cx="1659953" cy="333248"/>
+            <a:off x="6618287" y="3584448"/>
+            <a:ext cx="1841881" cy="514858"/>
           </a:xfrm>
           <a:prstGeom prst="roundRect">
             <a:avLst>
-              <a:gd name="adj" fmla="val 24695"/>
+              <a:gd name="adj" fmla="val 15984"/>
             </a:avLst>
           </a:prstGeom>
           <a:solidFill>
@@ -15239,7 +15225,7 @@
           <a:p>
             <a:pPr algn="ctr"/>
             <a:r>
-              <a:rPr sz="1150" b="0">
+              <a:rPr sz="1300" b="0">
                 <a:solidFill>
                   <a:srgbClr val="4A4842"/>
                 </a:solidFill>
@@ -15260,12 +15246,12 @@
         </p:nvSpPr>
         <p:spPr>
           <a:xfrm>
-            <a:off x="6940010" y="3904488"/>
-            <a:ext cx="1198435" cy="333248"/>
+            <a:off x="6879145" y="4245610"/>
+            <a:ext cx="1320165" cy="514858"/>
           </a:xfrm>
           <a:prstGeom prst="roundRect">
             <a:avLst>
-              <a:gd name="adj" fmla="val 24695"/>
+              <a:gd name="adj" fmla="val 15984"/>
             </a:avLst>
           </a:prstGeom>
           <a:solidFill>
@@ -15298,7 +15284,7 @@
           <a:p>
             <a:pPr algn="ctr"/>
             <a:r>
-              <a:rPr sz="1150" b="0">
+              <a:rPr sz="1300" b="0">
                 <a:solidFill>
                   <a:srgbClr val="4A4842"/>
                 </a:solidFill>
@@ -15319,12 +15305,12 @@
         </p:nvSpPr>
         <p:spPr>
           <a:xfrm>
-            <a:off x="6718744" y="4288536"/>
-            <a:ext cx="1640966" cy="333248"/>
+            <a:off x="6629019" y="4906772"/>
+            <a:ext cx="1820417" cy="514858"/>
           </a:xfrm>
           <a:prstGeom prst="roundRect">
             <a:avLst>
-              <a:gd name="adj" fmla="val 24695"/>
+              <a:gd name="adj" fmla="val 15984"/>
             </a:avLst>
           </a:prstGeom>
           <a:solidFill>
@@ -15357,7 +15343,7 @@
           <a:p>
             <a:pPr algn="ctr"/>
             <a:r>
-              <a:rPr sz="1150" b="0">
+              <a:rPr sz="1300" b="0">
                 <a:solidFill>
                   <a:srgbClr val="4A4842"/>
                 </a:solidFill>
@@ -15378,8 +15364,8 @@
         </p:nvSpPr>
         <p:spPr>
           <a:xfrm>
-            <a:off x="5504688" y="5047488"/>
-            <a:ext cx="4069079" cy="365760"/>
+            <a:off x="5504688" y="5550408"/>
+            <a:ext cx="4069079" cy="347472"/>
           </a:xfrm>
           <a:prstGeom prst="rect">
             <a:avLst/>
@@ -15394,7 +15380,44 @@
           <a:p>
             <a:pPr algn="ctr"/>
             <a:r>
-              <a:rPr sz="1000" b="0">
+              <a:rPr sz="1050" b="0">
+                <a:solidFill>
+                  <a:srgbClr val="6F6B5E"/>
+                </a:solidFill>
+                <a:latin typeface="Readex Pro"/>
+                <a:cs typeface="Readex Pro"/>
+                <a:ea typeface="Readex Pro"/>
+              </a:rPr>
+              <a:t>people barely agree on these: never used to decide</a:t>
+            </a:r>
+          </a:p>
+        </p:txBody>
+      </p:sp>
+      <p:sp>
+        <p:nvSpPr>
+          <p:cNvPr id="28" name="TextBox 27"/>
+          <p:cNvSpPr txBox="1"/>
+          <p:nvPr/>
+        </p:nvSpPr>
+        <p:spPr>
+          <a:xfrm>
+            <a:off x="5504688" y="5550408"/>
+            <a:ext cx="4069079" cy="347472"/>
+          </a:xfrm>
+          <a:prstGeom prst="rect">
+            <a:avLst/>
+          </a:prstGeom>
+          <a:noFill/>
+        </p:spPr>
+        <p:txBody>
+          <a:bodyPr wrap="square" lIns="0" rIns="0" tIns="0" bIns="0" anchor="ctr">
+            <a:spAutoFit/>
+          </a:bodyPr>
+          <a:lstStyle/>
+          <a:p>
+            <a:pPr algn="ctr"/>
+            <a:r>
+              <a:rPr sz="1050" b="0">
                 <a:solidFill>
                   <a:srgbClr val="6F6B5E"/>
                 </a:solidFill>
@@ -16677,11 +16700,11 @@
         <p:spPr>
           <a:xfrm>
             <a:off x="566928" y="3657600"/>
-            <a:ext cx="3045968" cy="333248"/>
+            <a:ext cx="3045968" cy="339090"/>
           </a:xfrm>
           <a:prstGeom prst="roundRect">
             <a:avLst>
-              <a:gd name="adj" fmla="val 24695"/>
+              <a:gd name="adj" fmla="val 24269"/>
             </a:avLst>
           </a:prstGeom>
           <a:solidFill>
@@ -16736,11 +16759,11 @@
         <p:spPr>
           <a:xfrm>
             <a:off x="566928" y="4160520"/>
-            <a:ext cx="3250438" cy="333248"/>
+            <a:ext cx="3250438" cy="339090"/>
           </a:xfrm>
           <a:prstGeom prst="roundRect">
             <a:avLst>
-              <a:gd name="adj" fmla="val 24695"/>
+              <a:gd name="adj" fmla="val 24269"/>
             </a:avLst>
           </a:prstGeom>
           <a:solidFill>
@@ -16795,11 +16818,11 @@
         <p:spPr>
           <a:xfrm>
             <a:off x="566928" y="4663440"/>
-            <a:ext cx="2604897" cy="333248"/>
+            <a:ext cx="2604897" cy="339090"/>
           </a:xfrm>
           <a:prstGeom prst="roundRect">
             <a:avLst>
-              <a:gd name="adj" fmla="val 24695"/>
+              <a:gd name="adj" fmla="val 24269"/>
             </a:avLst>
           </a:prstGeom>
           <a:solidFill>
@@ -17518,13 +17541,13 @@
         </p:nvCxnSpPr>
         <p:spPr>
           <a:xfrm>
-            <a:off x="1069848" y="5212080"/>
-            <a:ext cx="4892040" cy="0"/>
+            <a:off x="2148840" y="5120640"/>
+            <a:ext cx="4617720" cy="0"/>
           </a:xfrm>
           <a:prstGeom prst="line">
             <a:avLst/>
           </a:prstGeom>
-          <a:ln w="19050">
+          <a:ln w="22225">
             <a:solidFill>
               <a:srgbClr val="A29D8C"/>
             </a:solidFill>
@@ -17553,13 +17576,13 @@
         </p:nvCxnSpPr>
         <p:spPr>
           <a:xfrm>
-            <a:off x="1069848" y="1691640"/>
-            <a:ext cx="0" cy="3520440"/>
+            <a:off x="2148840" y="1874519"/>
+            <a:ext cx="0" cy="3246121"/>
           </a:xfrm>
           <a:prstGeom prst="line">
             <a:avLst/>
           </a:prstGeom>
-          <a:ln w="19050">
+          <a:ln w="22225">
             <a:solidFill>
               <a:srgbClr val="A29D8C"/>
             </a:solidFill>
@@ -17588,8 +17611,8 @@
         </p:nvSpPr>
         <p:spPr>
           <a:xfrm>
-            <a:off x="1069848" y="5303520"/>
-            <a:ext cx="4892040" cy="237744"/>
+            <a:off x="2148840" y="5230368"/>
+            <a:ext cx="4617720" cy="256032"/>
           </a:xfrm>
           <a:prstGeom prst="rect">
             <a:avLst/>
@@ -17604,7 +17627,7 @@
           <a:p>
             <a:pPr algn="ctr"/>
             <a:r>
-              <a:rPr sz="1100" b="0">
+              <a:rPr sz="1150" b="0">
                 <a:solidFill>
                   <a:srgbClr val="6F6B5E"/>
                 </a:solidFill>
@@ -17624,9 +17647,9 @@
           <p:nvPr/>
         </p:nvSpPr>
         <p:spPr>
-          <a:xfrm>
-            <a:off x="521207" y="3131820"/>
-            <a:ext cx="960120" cy="640080"/>
+          <a:xfrm rot="16200000">
+            <a:off x="1673352" y="3369563"/>
+            <a:ext cx="3291840" cy="256032"/>
           </a:xfrm>
           <a:prstGeom prst="rect">
             <a:avLst/>
@@ -17641,7 +17664,7 @@
           <a:p>
             <a:pPr algn="ctr"/>
             <a:r>
-              <a:rPr sz="1100" b="0">
+              <a:rPr sz="1150" b="0">
                 <a:solidFill>
                   <a:srgbClr val="6F6B5E"/>
                 </a:solidFill>
@@ -17649,21 +17672,7 @@
                 <a:cs typeface="Readex Pro"/>
                 <a:ea typeface="Readex Pro"/>
               </a:rPr>
-              <a:t>clause words</a:t>
-            </a:r>
-          </a:p>
-          <a:p>
-            <a:pPr algn="ctr"/>
-            <a:r>
-              <a:rPr sz="1100" b="0">
-                <a:solidFill>
-                  <a:srgbClr val="6F6B5E"/>
-                </a:solidFill>
-                <a:latin typeface="Readex Pro"/>
-                <a:cs typeface="Readex Pro"/>
-                <a:ea typeface="Readex Pro"/>
-              </a:rPr>
-              <a:t>shorter  →</a:t>
+              <a:t>simplification: words cut from the longest clause  →</a:t>
             </a:r>
           </a:p>
         </p:txBody>
@@ -17676,8 +17685,8 @@
         </p:nvSpPr>
         <p:spPr>
           <a:xfrm>
-            <a:off x="5535167" y="4853902"/>
-            <a:ext cx="201168" cy="201168"/>
+            <a:off x="6353555" y="4777963"/>
+            <a:ext cx="210312" cy="210312"/>
           </a:xfrm>
           <a:prstGeom prst="ellipse">
             <a:avLst/>
@@ -17720,8 +17729,8 @@
         </p:nvSpPr>
         <p:spPr>
           <a:xfrm>
-            <a:off x="4767072" y="4570438"/>
-            <a:ext cx="1737360" cy="237744"/>
+            <a:off x="5836920" y="4467067"/>
+            <a:ext cx="1243584" cy="237744"/>
           </a:xfrm>
           <a:prstGeom prst="rect">
             <a:avLst/>
@@ -17734,9 +17743,9 @@
           </a:bodyPr>
           <a:lstStyle/>
           <a:p>
-            <a:pPr algn="ctr"/>
-            <a:r>
-              <a:rPr sz="1100" b="0">
+            <a:pPr algn="l"/>
+            <a:r>
+              <a:rPr sz="1200" b="0">
                 <a:solidFill>
                   <a:srgbClr val="4A4842"/>
                 </a:solidFill>
@@ -17744,7 +17753,7 @@
                 <a:cs typeface="Readex Pro"/>
                 <a:ea typeface="Readex Pro"/>
               </a:rPr>
-              <a:t>copy</a:t>
+              <a:t>Copy the input</a:t>
             </a:r>
           </a:p>
         </p:txBody>
@@ -17757,8 +17766,538 @@
         </p:nvSpPr>
         <p:spPr>
           <a:xfrm>
-            <a:off x="4126260" y="4166987"/>
-            <a:ext cx="201168" cy="201168"/>
+            <a:off x="4875885" y="4777963"/>
+            <a:ext cx="210312" cy="210312"/>
+          </a:xfrm>
+          <a:prstGeom prst="ellipse">
+            <a:avLst/>
+          </a:prstGeom>
+          <a:solidFill>
+            <a:srgbClr val="6F6B5E"/>
+          </a:solidFill>
+          <a:ln>
+            <a:noFill/>
+          </a:ln>
+          <a:effectLst/>
+        </p:spPr>
+        <p:style>
+          <a:lnRef idx="1">
+            <a:schemeClr val="accent1"/>
+          </a:lnRef>
+          <a:fillRef idx="3">
+            <a:schemeClr val="accent1"/>
+          </a:fillRef>
+          <a:effectRef idx="2">
+            <a:schemeClr val="accent1"/>
+          </a:effectRef>
+          <a:fontRef idx="minor">
+            <a:schemeClr val="lt1"/>
+          </a:fontRef>
+        </p:style>
+        <p:txBody>
+          <a:bodyPr rtlCol="0" anchor="ctr"/>
+          <a:lstStyle/>
+          <a:p>
+            <a:pPr algn="ctr"/>
+          </a:p>
+        </p:txBody>
+      </p:sp>
+      <p:sp>
+        <p:nvSpPr>
+          <p:cNvPr id="16" name="TextBox 15"/>
+          <p:cNvSpPr txBox="1"/>
+          <p:nvPr/>
+        </p:nvSpPr>
+        <p:spPr>
+          <a:xfrm>
+            <a:off x="4788255" y="4467067"/>
+            <a:ext cx="385572" cy="237744"/>
+          </a:xfrm>
+          <a:prstGeom prst="rect">
+            <a:avLst/>
+          </a:prstGeom>
+          <a:noFill/>
+        </p:spPr>
+        <p:txBody>
+          <a:bodyPr wrap="square" lIns="0" rIns="0" tIns="0" bIns="0" anchor="ctr">
+            <a:spAutoFit/>
+          </a:bodyPr>
+          <a:lstStyle/>
+          <a:p>
+            <a:pPr algn="l"/>
+            <a:r>
+              <a:rPr sz="1200" b="0">
+                <a:solidFill>
+                  <a:srgbClr val="4A4842"/>
+                </a:solidFill>
+                <a:latin typeface="Readex Pro"/>
+                <a:cs typeface="Readex Pro"/>
+                <a:ea typeface="Readex Pro"/>
+              </a:rPr>
+              <a:t>v0.1</a:t>
+            </a:r>
+          </a:p>
+        </p:txBody>
+      </p:sp>
+      <p:sp>
+        <p:nvSpPr>
+          <p:cNvPr id="17" name="Oval 16"/>
+          <p:cNvSpPr/>
+          <p:nvPr/>
+        </p:nvSpPr>
+        <p:spPr>
+          <a:xfrm>
+            <a:off x="5035966" y="4025813"/>
+            <a:ext cx="210312" cy="210312"/>
+          </a:xfrm>
+          <a:prstGeom prst="ellipse">
+            <a:avLst/>
+          </a:prstGeom>
+          <a:solidFill>
+            <a:srgbClr val="6F6B5E"/>
+          </a:solidFill>
+          <a:ln>
+            <a:noFill/>
+          </a:ln>
+          <a:effectLst/>
+        </p:spPr>
+        <p:style>
+          <a:lnRef idx="1">
+            <a:schemeClr val="accent1"/>
+          </a:lnRef>
+          <a:fillRef idx="3">
+            <a:schemeClr val="accent1"/>
+          </a:fillRef>
+          <a:effectRef idx="2">
+            <a:schemeClr val="accent1"/>
+          </a:effectRef>
+          <a:fontRef idx="minor">
+            <a:schemeClr val="lt1"/>
+          </a:fontRef>
+        </p:style>
+        <p:txBody>
+          <a:bodyPr rtlCol="0" anchor="ctr"/>
+          <a:lstStyle/>
+          <a:p>
+            <a:pPr algn="ctr"/>
+          </a:p>
+        </p:txBody>
+      </p:sp>
+      <p:sp>
+        <p:nvSpPr>
+          <p:cNvPr id="18" name="TextBox 17"/>
+          <p:cNvSpPr txBox="1"/>
+          <p:nvPr/>
+        </p:nvSpPr>
+        <p:spPr>
+          <a:xfrm>
+            <a:off x="4507900" y="3714917"/>
+            <a:ext cx="1266443" cy="237744"/>
+          </a:xfrm>
+          <a:prstGeom prst="rect">
+            <a:avLst/>
+          </a:prstGeom>
+          <a:noFill/>
+        </p:spPr>
+        <p:txBody>
+          <a:bodyPr wrap="square" lIns="0" rIns="0" tIns="0" bIns="0" anchor="ctr">
+            <a:spAutoFit/>
+          </a:bodyPr>
+          <a:lstStyle/>
+          <a:p>
+            <a:pPr algn="l"/>
+            <a:r>
+              <a:rPr sz="1200" b="0">
+                <a:solidFill>
+                  <a:srgbClr val="4A4842"/>
+                </a:solidFill>
+                <a:latin typeface="Readex Pro"/>
+                <a:cs typeface="Readex Pro"/>
+                <a:ea typeface="Readex Pro"/>
+              </a:rPr>
+              <a:t>v0.2 in the app</a:t>
+            </a:r>
+          </a:p>
+        </p:txBody>
+      </p:sp>
+      <p:sp>
+        <p:nvSpPr>
+          <p:cNvPr id="19" name="Oval 18"/>
+          <p:cNvSpPr/>
+          <p:nvPr/>
+        </p:nvSpPr>
+        <p:spPr>
+          <a:xfrm>
+            <a:off x="4401799" y="2996555"/>
+            <a:ext cx="210312" cy="210312"/>
+          </a:xfrm>
+          <a:prstGeom prst="ellipse">
+            <a:avLst/>
+          </a:prstGeom>
+          <a:solidFill>
+            <a:srgbClr val="6F6B5E"/>
+          </a:solidFill>
+          <a:ln>
+            <a:noFill/>
+          </a:ln>
+          <a:effectLst/>
+        </p:spPr>
+        <p:style>
+          <a:lnRef idx="1">
+            <a:schemeClr val="accent1"/>
+          </a:lnRef>
+          <a:fillRef idx="3">
+            <a:schemeClr val="accent1"/>
+          </a:fillRef>
+          <a:effectRef idx="2">
+            <a:schemeClr val="accent1"/>
+          </a:effectRef>
+          <a:fontRef idx="minor">
+            <a:schemeClr val="lt1"/>
+          </a:fontRef>
+        </p:style>
+        <p:txBody>
+          <a:bodyPr rtlCol="0" anchor="ctr"/>
+          <a:lstStyle/>
+          <a:p>
+            <a:pPr algn="ctr"/>
+          </a:p>
+        </p:txBody>
+      </p:sp>
+      <p:sp>
+        <p:nvSpPr>
+          <p:cNvPr id="20" name="TextBox 19"/>
+          <p:cNvSpPr txBox="1"/>
+          <p:nvPr/>
+        </p:nvSpPr>
+        <p:spPr>
+          <a:xfrm>
+            <a:off x="3257783" y="2982839"/>
+            <a:ext cx="1052576" cy="237744"/>
+          </a:xfrm>
+          <a:prstGeom prst="rect">
+            <a:avLst/>
+          </a:prstGeom>
+          <a:noFill/>
+        </p:spPr>
+        <p:txBody>
+          <a:bodyPr wrap="square" lIns="0" rIns="0" tIns="0" bIns="0" anchor="ctr">
+            <a:spAutoFit/>
+          </a:bodyPr>
+          <a:lstStyle/>
+          <a:p>
+            <a:pPr algn="l"/>
+            <a:r>
+              <a:rPr sz="1100" b="0">
+                <a:solidFill>
+                  <a:srgbClr val="4A4842"/>
+                </a:solidFill>
+                <a:latin typeface="Readex Pro"/>
+                <a:cs typeface="Readex Pro"/>
+                <a:ea typeface="Readex Pro"/>
+              </a:rPr>
+              <a:t>v0.2 (no tag)</a:t>
+            </a:r>
+          </a:p>
+        </p:txBody>
+      </p:sp>
+      <p:sp>
+        <p:nvSpPr>
+          <p:cNvPr id="21" name="Oval 20"/>
+          <p:cNvSpPr/>
+          <p:nvPr/>
+        </p:nvSpPr>
+        <p:spPr>
+          <a:xfrm>
+            <a:off x="3859987" y="2283992"/>
+            <a:ext cx="210312" cy="210312"/>
+          </a:xfrm>
+          <a:prstGeom prst="ellipse">
+            <a:avLst/>
+          </a:prstGeom>
+          <a:solidFill>
+            <a:srgbClr val="6F6B5E"/>
+          </a:solidFill>
+          <a:ln>
+            <a:noFill/>
+          </a:ln>
+          <a:effectLst/>
+        </p:spPr>
+        <p:style>
+          <a:lnRef idx="1">
+            <a:schemeClr val="accent1"/>
+          </a:lnRef>
+          <a:fillRef idx="3">
+            <a:schemeClr val="accent1"/>
+          </a:fillRef>
+          <a:effectRef idx="2">
+            <a:schemeClr val="accent1"/>
+          </a:effectRef>
+          <a:fontRef idx="minor">
+            <a:schemeClr val="lt1"/>
+          </a:fontRef>
+        </p:style>
+        <p:txBody>
+          <a:bodyPr rtlCol="0" anchor="ctr"/>
+          <a:lstStyle/>
+          <a:p>
+            <a:pPr algn="ctr"/>
+          </a:p>
+        </p:txBody>
+      </p:sp>
+      <p:sp>
+        <p:nvSpPr>
+          <p:cNvPr id="22" name="TextBox 21"/>
+          <p:cNvSpPr txBox="1"/>
+          <p:nvPr/>
+        </p:nvSpPr>
+        <p:spPr>
+          <a:xfrm>
+            <a:off x="3554107" y="2567456"/>
+            <a:ext cx="822070" cy="237744"/>
+          </a:xfrm>
+          <a:prstGeom prst="rect">
+            <a:avLst/>
+          </a:prstGeom>
+          <a:noFill/>
+        </p:spPr>
+        <p:txBody>
+          <a:bodyPr wrap="square" lIns="0" rIns="0" tIns="0" bIns="0" anchor="ctr">
+            <a:spAutoFit/>
+          </a:bodyPr>
+          <a:lstStyle/>
+          <a:p>
+            <a:pPr algn="l"/>
+            <a:r>
+              <a:rPr sz="1100" b="0">
+                <a:solidFill>
+                  <a:srgbClr val="4A4842"/>
+                </a:solidFill>
+                <a:latin typeface="Readex Pro"/>
+                <a:cs typeface="Readex Pro"/>
+                <a:ea typeface="Readex Pro"/>
+              </a:rPr>
+              <a:t>v0.2 + tag</a:t>
+            </a:r>
+          </a:p>
+        </p:txBody>
+      </p:sp>
+      <p:sp>
+        <p:nvSpPr>
+          <p:cNvPr id="23" name="Oval 22"/>
+          <p:cNvSpPr/>
+          <p:nvPr/>
+        </p:nvSpPr>
+        <p:spPr>
+          <a:xfrm>
+            <a:off x="3361273" y="2838208"/>
+            <a:ext cx="210312" cy="210312"/>
+          </a:xfrm>
+          <a:prstGeom prst="ellipse">
+            <a:avLst/>
+          </a:prstGeom>
+          <a:solidFill>
+            <a:srgbClr val="6F6B5E"/>
+          </a:solidFill>
+          <a:ln>
+            <a:noFill/>
+          </a:ln>
+          <a:effectLst/>
+        </p:spPr>
+        <p:style>
+          <a:lnRef idx="1">
+            <a:schemeClr val="accent1"/>
+          </a:lnRef>
+          <a:fillRef idx="3">
+            <a:schemeClr val="accent1"/>
+          </a:fillRef>
+          <a:effectRef idx="2">
+            <a:schemeClr val="accent1"/>
+          </a:effectRef>
+          <a:fontRef idx="minor">
+            <a:schemeClr val="lt1"/>
+          </a:fontRef>
+        </p:style>
+        <p:txBody>
+          <a:bodyPr rtlCol="0" anchor="ctr"/>
+          <a:lstStyle/>
+          <a:p>
+            <a:pPr algn="ctr"/>
+          </a:p>
+        </p:txBody>
+      </p:sp>
+      <p:sp>
+        <p:nvSpPr>
+          <p:cNvPr id="24" name="TextBox 23"/>
+          <p:cNvSpPr txBox="1"/>
+          <p:nvPr/>
+        </p:nvSpPr>
+        <p:spPr>
+          <a:xfrm>
+            <a:off x="2738973" y="3121672"/>
+            <a:ext cx="1454912" cy="237744"/>
+          </a:xfrm>
+          <a:prstGeom prst="rect">
+            <a:avLst/>
+          </a:prstGeom>
+          <a:noFill/>
+        </p:spPr>
+        <p:txBody>
+          <a:bodyPr wrap="square" lIns="0" rIns="0" tIns="0" bIns="0" anchor="ctr">
+            <a:spAutoFit/>
+          </a:bodyPr>
+          <a:lstStyle/>
+          <a:p>
+            <a:pPr algn="l"/>
+            <a:r>
+              <a:rPr sz="1100" b="0">
+                <a:solidFill>
+                  <a:srgbClr val="4A4842"/>
+                </a:solidFill>
+                <a:latin typeface="Readex Pro"/>
+                <a:cs typeface="Readex Pro"/>
+                <a:ea typeface="Readex Pro"/>
+              </a:rPr>
+              <a:t>v0.2-Fast (no tag)</a:t>
+            </a:r>
+          </a:p>
+        </p:txBody>
+      </p:sp>
+      <p:sp>
+        <p:nvSpPr>
+          <p:cNvPr id="25" name="Oval 24"/>
+          <p:cNvSpPr/>
+          <p:nvPr/>
+        </p:nvSpPr>
+        <p:spPr>
+          <a:xfrm>
+            <a:off x="2665536" y="2125645"/>
+            <a:ext cx="210312" cy="210312"/>
+          </a:xfrm>
+          <a:prstGeom prst="ellipse">
+            <a:avLst/>
+          </a:prstGeom>
+          <a:solidFill>
+            <a:srgbClr val="6F6B5E"/>
+          </a:solidFill>
+          <a:ln>
+            <a:noFill/>
+          </a:ln>
+          <a:effectLst/>
+        </p:spPr>
+        <p:style>
+          <a:lnRef idx="1">
+            <a:schemeClr val="accent1"/>
+          </a:lnRef>
+          <a:fillRef idx="3">
+            <a:schemeClr val="accent1"/>
+          </a:fillRef>
+          <a:effectRef idx="2">
+            <a:schemeClr val="accent1"/>
+          </a:effectRef>
+          <a:fontRef idx="minor">
+            <a:schemeClr val="lt1"/>
+          </a:fontRef>
+        </p:style>
+        <p:txBody>
+          <a:bodyPr rtlCol="0" anchor="ctr"/>
+          <a:lstStyle/>
+          <a:p>
+            <a:pPr algn="ctr"/>
+          </a:p>
+        </p:txBody>
+      </p:sp>
+      <p:sp>
+        <p:nvSpPr>
+          <p:cNvPr id="26" name="TextBox 25"/>
+          <p:cNvSpPr txBox="1"/>
+          <p:nvPr/>
+        </p:nvSpPr>
+        <p:spPr>
+          <a:xfrm>
+            <a:off x="2985576" y="2111929"/>
+            <a:ext cx="1224407" cy="237744"/>
+          </a:xfrm>
+          <a:prstGeom prst="rect">
+            <a:avLst/>
+          </a:prstGeom>
+          <a:noFill/>
+        </p:spPr>
+        <p:txBody>
+          <a:bodyPr wrap="square" lIns="0" rIns="0" tIns="0" bIns="0" anchor="ctr">
+            <a:spAutoFit/>
+          </a:bodyPr>
+          <a:lstStyle/>
+          <a:p>
+            <a:pPr algn="l"/>
+            <a:r>
+              <a:rPr sz="1100" b="0">
+                <a:solidFill>
+                  <a:srgbClr val="4A4842"/>
+                </a:solidFill>
+                <a:latin typeface="Readex Pro"/>
+                <a:cs typeface="Readex Pro"/>
+                <a:ea typeface="Readex Pro"/>
+              </a:rPr>
+              <a:t>v0.2-Fast + tag</a:t>
+            </a:r>
+          </a:p>
+        </p:txBody>
+      </p:sp>
+      <p:sp>
+        <p:nvSpPr>
+          <p:cNvPr id="27" name="Oval 26"/>
+          <p:cNvSpPr/>
+          <p:nvPr/>
+        </p:nvSpPr>
+        <p:spPr>
+          <a:xfrm>
+            <a:off x="5094427" y="2568571"/>
+            <a:ext cx="512064" cy="512064"/>
+          </a:xfrm>
+          <a:prstGeom prst="ellipse">
+            <a:avLst/>
+          </a:prstGeom>
+          <a:noFill/>
+          <a:ln w="22225">
+            <a:solidFill>
+              <a:srgbClr val="C6986B"/>
+            </a:solidFill>
+          </a:ln>
+          <a:effectLst/>
+        </p:spPr>
+        <p:style>
+          <a:lnRef idx="1">
+            <a:schemeClr val="accent1"/>
+          </a:lnRef>
+          <a:fillRef idx="3">
+            <a:schemeClr val="accent1"/>
+          </a:fillRef>
+          <a:effectRef idx="2">
+            <a:schemeClr val="accent1"/>
+          </a:effectRef>
+          <a:fontRef idx="minor">
+            <a:schemeClr val="lt1"/>
+          </a:fontRef>
+        </p:style>
+        <p:txBody>
+          <a:bodyPr rtlCol="0" anchor="ctr"/>
+          <a:lstStyle/>
+          <a:p>
+            <a:pPr algn="ctr"/>
+          </a:p>
+        </p:txBody>
+      </p:sp>
+      <p:sp>
+        <p:nvSpPr>
+          <p:cNvPr id="28" name="Oval 27"/>
+          <p:cNvSpPr/>
+          <p:nvPr/>
+        </p:nvSpPr>
+        <p:spPr>
+          <a:xfrm>
+            <a:off x="5204155" y="2678299"/>
+            <a:ext cx="292608" cy="292608"/>
           </a:xfrm>
           <a:prstGeom prst="ellipse">
             <a:avLst/>
@@ -17795,14 +18334,14 @@
       </p:sp>
       <p:sp>
         <p:nvSpPr>
-          <p:cNvPr id="16" name="TextBox 15"/>
+          <p:cNvPr id="29" name="TextBox 28"/>
           <p:cNvSpPr txBox="1"/>
           <p:nvPr/>
         </p:nvSpPr>
         <p:spPr>
           <a:xfrm>
-            <a:off x="3358164" y="3883523"/>
-            <a:ext cx="1737360" cy="237744"/>
+            <a:off x="5606491" y="2705731"/>
+            <a:ext cx="1364361" cy="237744"/>
           </a:xfrm>
           <a:prstGeom prst="rect">
             <a:avLst/>
@@ -17815,412 +18354,30 @@
           </a:bodyPr>
           <a:lstStyle/>
           <a:p>
-            <a:pPr algn="ctr"/>
-            <a:r>
-              <a:rPr sz="1100" b="0">
-                <a:solidFill>
-                  <a:srgbClr val="4A4842"/>
-                </a:solidFill>
-                <a:latin typeface="Readex Pro"/>
-                <a:cs typeface="Readex Pro"/>
-                <a:ea typeface="Readex Pro"/>
-              </a:rPr>
-              <a:t>app-arat5 (today)</a:t>
-            </a:r>
-          </a:p>
-        </p:txBody>
-      </p:sp>
-      <p:sp>
-        <p:nvSpPr>
-          <p:cNvPr id="17" name="Oval 16"/>
+            <a:pPr algn="l"/>
+            <a:r>
+              <a:rPr sz="1300" b="1">
+                <a:solidFill>
+                  <a:srgbClr val="B5533C"/>
+                </a:solidFill>
+                <a:latin typeface="Readex Pro"/>
+                <a:cs typeface="Readex Pro"/>
+                <a:ea typeface="Readex Pro"/>
+              </a:rPr>
+              <a:t>v0.3 in the app</a:t>
+            </a:r>
+          </a:p>
+        </p:txBody>
+      </p:sp>
+      <p:sp>
+        <p:nvSpPr>
+          <p:cNvPr id="30" name="Rectangle 29"/>
           <p:cNvSpPr/>
           <p:nvPr/>
         </p:nvSpPr>
         <p:spPr>
           <a:xfrm>
-            <a:off x="4087124" y="3308343"/>
-            <a:ext cx="201168" cy="201168"/>
-          </a:xfrm>
-          <a:prstGeom prst="ellipse">
-            <a:avLst/>
-          </a:prstGeom>
-          <a:solidFill>
-            <a:srgbClr val="6F6B5E"/>
-          </a:solidFill>
-          <a:ln>
-            <a:noFill/>
-          </a:ln>
-          <a:effectLst/>
-        </p:spPr>
-        <p:style>
-          <a:lnRef idx="1">
-            <a:schemeClr val="accent1"/>
-          </a:lnRef>
-          <a:fillRef idx="3">
-            <a:schemeClr val="accent1"/>
-          </a:fillRef>
-          <a:effectRef idx="2">
-            <a:schemeClr val="accent1"/>
-          </a:effectRef>
-          <a:fontRef idx="minor">
-            <a:schemeClr val="lt1"/>
-          </a:fontRef>
-        </p:style>
-        <p:txBody>
-          <a:bodyPr rtlCol="0" anchor="ctr"/>
-          <a:lstStyle/>
-          <a:p>
-            <a:pPr algn="ctr"/>
-          </a:p>
-        </p:txBody>
-      </p:sp>
-      <p:sp>
-        <p:nvSpPr>
-          <p:cNvPr id="18" name="Oval 17"/>
-          <p:cNvSpPr/>
-          <p:nvPr/>
-        </p:nvSpPr>
-        <p:spPr>
-          <a:xfrm>
-            <a:off x="3089148" y="2406767"/>
-            <a:ext cx="201168" cy="201168"/>
-          </a:xfrm>
-          <a:prstGeom prst="ellipse">
-            <a:avLst/>
-          </a:prstGeom>
-          <a:solidFill>
-            <a:srgbClr val="6F6B5E"/>
-          </a:solidFill>
-          <a:ln>
-            <a:noFill/>
-          </a:ln>
-          <a:effectLst/>
-        </p:spPr>
-        <p:style>
-          <a:lnRef idx="1">
-            <a:schemeClr val="accent1"/>
-          </a:lnRef>
-          <a:fillRef idx="3">
-            <a:schemeClr val="accent1"/>
-          </a:fillRef>
-          <a:effectRef idx="2">
-            <a:schemeClr val="accent1"/>
-          </a:effectRef>
-          <a:fontRef idx="minor">
-            <a:schemeClr val="lt1"/>
-          </a:fontRef>
-        </p:style>
-        <p:txBody>
-          <a:bodyPr rtlCol="0" anchor="ctr"/>
-          <a:lstStyle/>
-          <a:p>
-            <a:pPr algn="ctr"/>
-          </a:p>
-        </p:txBody>
-      </p:sp>
-      <p:sp>
-        <p:nvSpPr>
-          <p:cNvPr id="19" name="Oval 18"/>
-          <p:cNvSpPr/>
-          <p:nvPr/>
-        </p:nvSpPr>
-        <p:spPr>
-          <a:xfrm>
-            <a:off x="2580375" y="3136615"/>
-            <a:ext cx="201168" cy="201168"/>
-          </a:xfrm>
-          <a:prstGeom prst="ellipse">
-            <a:avLst/>
-          </a:prstGeom>
-          <a:solidFill>
-            <a:srgbClr val="8A5E35"/>
-          </a:solidFill>
-          <a:ln>
-            <a:noFill/>
-          </a:ln>
-          <a:effectLst/>
-        </p:spPr>
-        <p:style>
-          <a:lnRef idx="1">
-            <a:schemeClr val="accent1"/>
-          </a:lnRef>
-          <a:fillRef idx="3">
-            <a:schemeClr val="accent1"/>
-          </a:fillRef>
-          <a:effectRef idx="2">
-            <a:schemeClr val="accent1"/>
-          </a:effectRef>
-          <a:fontRef idx="minor">
-            <a:schemeClr val="lt1"/>
-          </a:fontRef>
-        </p:style>
-        <p:txBody>
-          <a:bodyPr rtlCol="0" anchor="ctr"/>
-          <a:lstStyle/>
-          <a:p>
-            <a:pPr algn="ctr"/>
-          </a:p>
-        </p:txBody>
-      </p:sp>
-      <p:sp>
-        <p:nvSpPr>
-          <p:cNvPr id="20" name="TextBox 19"/>
-          <p:cNvSpPr txBox="1"/>
-          <p:nvPr/>
-        </p:nvSpPr>
-        <p:spPr>
-          <a:xfrm>
-            <a:off x="1812279" y="2853151"/>
-            <a:ext cx="1737360" cy="237744"/>
-          </a:xfrm>
-          <a:prstGeom prst="rect">
-            <a:avLst/>
-          </a:prstGeom>
-          <a:noFill/>
-        </p:spPr>
-        <p:txBody>
-          <a:bodyPr wrap="square" lIns="0" rIns="0" tIns="0" bIns="0" anchor="ctr">
-            <a:spAutoFit/>
-          </a:bodyPr>
-          <a:lstStyle/>
-          <a:p>
-            <a:pPr algn="ctr"/>
-            <a:r>
-              <a:rPr sz="1100" b="0">
-                <a:solidFill>
-                  <a:srgbClr val="4A4842"/>
-                </a:solidFill>
-                <a:latin typeface="Readex Pro"/>
-                <a:cs typeface="Readex Pro"/>
-                <a:ea typeface="Readex Pro"/>
-              </a:rPr>
-              <a:t>app-arabart</a:t>
-            </a:r>
-          </a:p>
-        </p:txBody>
-      </p:sp>
-      <p:sp>
-        <p:nvSpPr>
-          <p:cNvPr id="21" name="Oval 20"/>
-          <p:cNvSpPr/>
-          <p:nvPr/>
-        </p:nvSpPr>
-        <p:spPr>
-          <a:xfrm>
-            <a:off x="2639080" y="3308343"/>
-            <a:ext cx="201168" cy="201168"/>
-          </a:xfrm>
-          <a:prstGeom prst="ellipse">
-            <a:avLst/>
-          </a:prstGeom>
-          <a:solidFill>
-            <a:srgbClr val="6F6B5E"/>
-          </a:solidFill>
-          <a:ln>
-            <a:noFill/>
-          </a:ln>
-          <a:effectLst/>
-        </p:spPr>
-        <p:style>
-          <a:lnRef idx="1">
-            <a:schemeClr val="accent1"/>
-          </a:lnRef>
-          <a:fillRef idx="3">
-            <a:schemeClr val="accent1"/>
-          </a:fillRef>
-          <a:effectRef idx="2">
-            <a:schemeClr val="accent1"/>
-          </a:effectRef>
-          <a:fontRef idx="minor">
-            <a:schemeClr val="lt1"/>
-          </a:fontRef>
-        </p:style>
-        <p:txBody>
-          <a:bodyPr rtlCol="0" anchor="ctr"/>
-          <a:lstStyle/>
-          <a:p>
-            <a:pPr algn="ctr"/>
-          </a:p>
-        </p:txBody>
-      </p:sp>
-      <p:sp>
-        <p:nvSpPr>
-          <p:cNvPr id="22" name="Oval 21"/>
-          <p:cNvSpPr/>
-          <p:nvPr/>
-        </p:nvSpPr>
-        <p:spPr>
-          <a:xfrm>
-            <a:off x="1745467" y="2277971"/>
-            <a:ext cx="201168" cy="201168"/>
-          </a:xfrm>
-          <a:prstGeom prst="ellipse">
-            <a:avLst/>
-          </a:prstGeom>
-          <a:solidFill>
-            <a:srgbClr val="6F6B5E"/>
-          </a:solidFill>
-          <a:ln>
-            <a:noFill/>
-          </a:ln>
-          <a:effectLst/>
-        </p:spPr>
-        <p:style>
-          <a:lnRef idx="1">
-            <a:schemeClr val="accent1"/>
-          </a:lnRef>
-          <a:fillRef idx="3">
-            <a:schemeClr val="accent1"/>
-          </a:fillRef>
-          <a:effectRef idx="2">
-            <a:schemeClr val="accent1"/>
-          </a:effectRef>
-          <a:fontRef idx="minor">
-            <a:schemeClr val="lt1"/>
-          </a:fontRef>
-        </p:style>
-        <p:txBody>
-          <a:bodyPr rtlCol="0" anchor="ctr"/>
-          <a:lstStyle/>
-          <a:p>
-            <a:pPr algn="ctr"/>
-          </a:p>
-        </p:txBody>
-      </p:sp>
-      <p:sp>
-        <p:nvSpPr>
-          <p:cNvPr id="23" name="Oval 22"/>
-          <p:cNvSpPr/>
-          <p:nvPr/>
-        </p:nvSpPr>
-        <p:spPr>
-          <a:xfrm>
-            <a:off x="4307433" y="2545488"/>
-            <a:ext cx="438912" cy="438912"/>
-          </a:xfrm>
-          <a:prstGeom prst="ellipse">
-            <a:avLst/>
-          </a:prstGeom>
-          <a:noFill/>
-          <a:ln w="19050">
-            <a:solidFill>
-              <a:srgbClr val="C6986B"/>
-            </a:solidFill>
-          </a:ln>
-          <a:effectLst/>
-        </p:spPr>
-        <p:style>
-          <a:lnRef idx="1">
-            <a:schemeClr val="accent1"/>
-          </a:lnRef>
-          <a:fillRef idx="3">
-            <a:schemeClr val="accent1"/>
-          </a:fillRef>
-          <a:effectRef idx="2">
-            <a:schemeClr val="accent1"/>
-          </a:effectRef>
-          <a:fontRef idx="minor">
-            <a:schemeClr val="lt1"/>
-          </a:fontRef>
-        </p:style>
-        <p:txBody>
-          <a:bodyPr rtlCol="0" anchor="ctr"/>
-          <a:lstStyle/>
-          <a:p>
-            <a:pPr algn="ctr"/>
-          </a:p>
-        </p:txBody>
-      </p:sp>
-      <p:sp>
-        <p:nvSpPr>
-          <p:cNvPr id="24" name="Oval 23"/>
-          <p:cNvSpPr/>
-          <p:nvPr/>
-        </p:nvSpPr>
-        <p:spPr>
-          <a:xfrm>
-            <a:off x="4398873" y="2636928"/>
-            <a:ext cx="256032" cy="256032"/>
-          </a:xfrm>
-          <a:prstGeom prst="ellipse">
-            <a:avLst/>
-          </a:prstGeom>
-          <a:solidFill>
-            <a:srgbClr val="B5533C"/>
-          </a:solidFill>
-          <a:ln>
-            <a:noFill/>
-          </a:ln>
-          <a:effectLst/>
-        </p:spPr>
-        <p:style>
-          <a:lnRef idx="1">
-            <a:schemeClr val="accent1"/>
-          </a:lnRef>
-          <a:fillRef idx="3">
-            <a:schemeClr val="accent1"/>
-          </a:fillRef>
-          <a:effectRef idx="2">
-            <a:schemeClr val="accent1"/>
-          </a:effectRef>
-          <a:fontRef idx="minor">
-            <a:schemeClr val="lt1"/>
-          </a:fontRef>
-        </p:style>
-        <p:txBody>
-          <a:bodyPr rtlCol="0" anchor="ctr"/>
-          <a:lstStyle/>
-          <a:p>
-            <a:pPr algn="ctr"/>
-          </a:p>
-        </p:txBody>
-      </p:sp>
-      <p:sp>
-        <p:nvSpPr>
-          <p:cNvPr id="25" name="TextBox 24"/>
-          <p:cNvSpPr txBox="1"/>
-          <p:nvPr/>
-        </p:nvSpPr>
-        <p:spPr>
-          <a:xfrm>
-            <a:off x="4709769" y="2618640"/>
-            <a:ext cx="1554480" cy="256032"/>
-          </a:xfrm>
-          <a:prstGeom prst="rect">
-            <a:avLst/>
-          </a:prstGeom>
-          <a:noFill/>
-        </p:spPr>
-        <p:txBody>
-          <a:bodyPr wrap="square" lIns="0" rIns="0" tIns="0" bIns="0" anchor="ctr">
-            <a:spAutoFit/>
-          </a:bodyPr>
-          <a:lstStyle/>
-          <a:p>
-            <a:pPr algn="l"/>
-            <a:r>
-              <a:rPr sz="1100" b="1">
-                <a:solidFill>
-                  <a:srgbClr val="B5533C"/>
-                </a:solidFill>
-                <a:latin typeface="Readex Pro"/>
-                <a:cs typeface="Readex Pro"/>
-                <a:ea typeface="Readex Pro"/>
-              </a:rPr>
-              <a:t>model 3 + net</a:t>
-            </a:r>
-          </a:p>
-        </p:txBody>
-      </p:sp>
-      <p:sp>
-        <p:nvSpPr>
-          <p:cNvPr id="26" name="Rectangle 25"/>
-          <p:cNvSpPr/>
-          <p:nvPr/>
-        </p:nvSpPr>
-        <p:spPr>
-          <a:xfrm>
-            <a:off x="1207007" y="5650992"/>
+            <a:off x="2240280" y="5605272"/>
             <a:ext cx="45720" cy="146304"/>
           </a:xfrm>
           <a:prstGeom prst="rect">
@@ -18258,13 +18415,13 @@
       </p:sp>
       <p:sp>
         <p:nvSpPr>
-          <p:cNvPr id="27" name="TextBox 26"/>
+          <p:cNvPr id="31" name="TextBox 30"/>
           <p:cNvSpPr txBox="1"/>
           <p:nvPr/>
         </p:nvSpPr>
         <p:spPr>
           <a:xfrm>
-            <a:off x="1316736" y="5623560"/>
+            <a:off x="2350008" y="5577840"/>
             <a:ext cx="5943600" cy="201168"/>
           </a:xfrm>
           <a:prstGeom prst="rect">
@@ -18295,18 +18452,178 @@
       </p:sp>
       <p:sp>
         <p:nvSpPr>
-          <p:cNvPr id="28" name="Rounded Rectangle 27"/>
+          <p:cNvPr id="32" name="Rounded Rectangle 31"/>
           <p:cNvSpPr/>
           <p:nvPr/>
         </p:nvSpPr>
         <p:spPr>
           <a:xfrm>
-            <a:off x="6464807" y="1874519"/>
-            <a:ext cx="2661412" cy="568960"/>
+            <a:off x="7178040" y="1874519"/>
+            <a:ext cx="2157984" cy="635508"/>
           </a:xfrm>
           <a:prstGeom prst="roundRect">
             <a:avLst>
-              <a:gd name="adj" fmla="val 14464"/>
+              <a:gd name="adj" fmla="val 14388"/>
+            </a:avLst>
+          </a:prstGeom>
+          <a:solidFill>
+            <a:srgbClr val="EEDDC7"/>
+          </a:solidFill>
+          <a:ln w="15875">
+            <a:solidFill>
+              <a:srgbClr val="EEDDC7"/>
+            </a:solidFill>
+          </a:ln>
+          <a:effectLst/>
+        </p:spPr>
+        <p:style>
+          <a:lnRef idx="1">
+            <a:schemeClr val="accent1"/>
+          </a:lnRef>
+          <a:fillRef idx="3">
+            <a:schemeClr val="accent1"/>
+          </a:fillRef>
+          <a:effectRef idx="2">
+            <a:schemeClr val="accent1"/>
+          </a:effectRef>
+          <a:fontRef idx="minor">
+            <a:schemeClr val="lt1"/>
+          </a:fontRef>
+        </p:style>
+        <p:txBody>
+          <a:bodyPr rtlCol="0" anchor="ctr" wrap="square" lIns="109728" rIns="109728" tIns="0" bIns="0"/>
+          <a:lstStyle/>
+          <a:p>
+            <a:pPr algn="ctr"/>
+            <a:r>
+              <a:rPr sz="1350" b="1">
+                <a:solidFill>
+                  <a:srgbClr val="8A5E35"/>
+                </a:solidFill>
+                <a:latin typeface="Readex Pro"/>
+                <a:cs typeface="Readex Pro"/>
+                <a:ea typeface="Readex Pro"/>
+              </a:rPr>
+              <a:t>the more it simplifies,</a:t>
+            </a:r>
+          </a:p>
+          <a:p>
+            <a:pPr algn="ctr"/>
+            <a:r>
+              <a:rPr sz="1350" b="1">
+                <a:solidFill>
+                  <a:srgbClr val="8A5E35"/>
+                </a:solidFill>
+                <a:latin typeface="Readex Pro"/>
+                <a:cs typeface="Readex Pro"/>
+                <a:ea typeface="Readex Pro"/>
+              </a:rPr>
+              <a:t>the less meaning it keeps, obviously</a:t>
+            </a:r>
+          </a:p>
+        </p:txBody>
+      </p:sp>
+      <p:sp>
+        <p:nvSpPr>
+          <p:cNvPr id="33" name="Rounded Rectangle 32"/>
+          <p:cNvSpPr/>
+          <p:nvPr/>
+        </p:nvSpPr>
+        <p:spPr>
+          <a:xfrm>
+            <a:off x="7178040" y="2711196"/>
+            <a:ext cx="2157984" cy="861822"/>
+          </a:xfrm>
+          <a:prstGeom prst="roundRect">
+            <a:avLst>
+              <a:gd name="adj" fmla="val 10610"/>
+            </a:avLst>
+          </a:prstGeom>
+          <a:solidFill>
+            <a:srgbClr val="C6986B"/>
+          </a:solidFill>
+          <a:ln w="15875">
+            <a:solidFill>
+              <a:srgbClr val="C6986B"/>
+            </a:solidFill>
+          </a:ln>
+          <a:effectLst/>
+        </p:spPr>
+        <p:style>
+          <a:lnRef idx="1">
+            <a:schemeClr val="accent1"/>
+          </a:lnRef>
+          <a:fillRef idx="3">
+            <a:schemeClr val="accent1"/>
+          </a:fillRef>
+          <a:effectRef idx="2">
+            <a:schemeClr val="accent1"/>
+          </a:effectRef>
+          <a:fontRef idx="minor">
+            <a:schemeClr val="lt1"/>
+          </a:fontRef>
+        </p:style>
+        <p:txBody>
+          <a:bodyPr rtlCol="0" anchor="ctr" wrap="square" lIns="109728" rIns="109728" tIns="0" bIns="0"/>
+          <a:lstStyle/>
+          <a:p>
+            <a:pPr algn="ctr"/>
+            <a:r>
+              <a:rPr sz="1350" b="1">
+                <a:solidFill>
+                  <a:srgbClr val="1A1A14"/>
+                </a:solidFill>
+                <a:latin typeface="Readex Pro"/>
+                <a:cs typeface="Readex Pro"/>
+                <a:ea typeface="Readex Pro"/>
+              </a:rPr>
+              <a:t>v0.3 keeps the most meaning (82%)</a:t>
+            </a:r>
+          </a:p>
+          <a:p>
+            <a:pPr algn="ctr"/>
+            <a:r>
+              <a:rPr sz="1350" b="1">
+                <a:solidFill>
+                  <a:srgbClr val="1A1A14"/>
+                </a:solidFill>
+                <a:latin typeface="Readex Pro"/>
+                <a:cs typeface="Readex Pro"/>
+                <a:ea typeface="Readex Pro"/>
+              </a:rPr>
+              <a:t>and still cuts 5.2 words off</a:t>
+            </a:r>
+          </a:p>
+          <a:p>
+            <a:pPr algn="ctr"/>
+            <a:r>
+              <a:rPr sz="1350" b="1">
+                <a:solidFill>
+                  <a:srgbClr val="1A1A14"/>
+                </a:solidFill>
+                <a:latin typeface="Readex Pro"/>
+                <a:cs typeface="Readex Pro"/>
+                <a:ea typeface="Readex Pro"/>
+              </a:rPr>
+              <a:t>the longest clause</a:t>
+            </a:r>
+          </a:p>
+        </p:txBody>
+      </p:sp>
+      <p:sp>
+        <p:nvSpPr>
+          <p:cNvPr id="34" name="Rounded Rectangle 33"/>
+          <p:cNvSpPr/>
+          <p:nvPr/>
+        </p:nvSpPr>
+        <p:spPr>
+          <a:xfrm>
+            <a:off x="7178040" y="3774185"/>
+            <a:ext cx="2157984" cy="601980"/>
+          </a:xfrm>
+          <a:prstGeom prst="roundRect">
+            <a:avLst>
+              <a:gd name="adj" fmla="val 15189"/>
             </a:avLst>
           </a:prstGeom>
           <a:solidFill>
@@ -18339,7 +18656,7 @@
           <a:p>
             <a:pPr algn="ctr"/>
             <a:r>
-              <a:rPr sz="1300" b="0">
+              <a:rPr sz="1250" b="0">
                 <a:solidFill>
                   <a:srgbClr val="4A4842"/>
                 </a:solidFill>
@@ -18347,13 +18664,13 @@
                 <a:cs typeface="Readex Pro"/>
                 <a:ea typeface="Readex Pro"/>
               </a:rPr>
-              <a:t>the more it simplifies,</a:t>
+              <a:t>v0.3 is the app's large model,</a:t>
             </a:r>
           </a:p>
           <a:p>
             <a:pPr algn="ctr"/>
             <a:r>
-              <a:rPr sz="1300" b="0">
+              <a:rPr sz="1250" b="0">
                 <a:solidFill>
                   <a:srgbClr val="4A4842"/>
                 </a:solidFill>
@@ -18361,153 +18678,7 @@
                 <a:cs typeface="Readex Pro"/>
                 <a:ea typeface="Readex Pro"/>
               </a:rPr>
-              <a:t>the less meaning it keeps</a:t>
-            </a:r>
-          </a:p>
-        </p:txBody>
-      </p:sp>
-      <p:sp>
-        <p:nvSpPr>
-          <p:cNvPr id="29" name="Rounded Rectangle 28"/>
-          <p:cNvSpPr/>
-          <p:nvPr/>
-        </p:nvSpPr>
-        <p:spPr>
-          <a:xfrm>
-            <a:off x="6464807" y="2788920"/>
-            <a:ext cx="2871216" cy="487680"/>
-          </a:xfrm>
-          <a:prstGeom prst="roundRect">
-            <a:avLst>
-              <a:gd name="adj" fmla="val 16875"/>
-            </a:avLst>
-          </a:prstGeom>
-          <a:solidFill>
-            <a:srgbClr val="C6986B"/>
-          </a:solidFill>
-          <a:ln w="15875">
-            <a:solidFill>
-              <a:srgbClr val="C6986B"/>
-            </a:solidFill>
-          </a:ln>
-          <a:effectLst/>
-        </p:spPr>
-        <p:style>
-          <a:lnRef idx="1">
-            <a:schemeClr val="accent1"/>
-          </a:lnRef>
-          <a:fillRef idx="3">
-            <a:schemeClr val="accent1"/>
-          </a:fillRef>
-          <a:effectRef idx="2">
-            <a:schemeClr val="accent1"/>
-          </a:effectRef>
-          <a:fontRef idx="minor">
-            <a:schemeClr val="lt1"/>
-          </a:fontRef>
-        </p:style>
-        <p:txBody>
-          <a:bodyPr rtlCol="0" anchor="ctr" wrap="square" lIns="109728" rIns="109728" tIns="0" bIns="0"/>
-          <a:lstStyle/>
-          <a:p>
-            <a:pPr algn="ctr"/>
-            <a:r>
-              <a:rPr sz="1050" b="1">
-                <a:solidFill>
-                  <a:srgbClr val="1A1A14"/>
-                </a:solidFill>
-                <a:latin typeface="Readex Pro"/>
-                <a:cs typeface="Readex Pro"/>
-                <a:ea typeface="Readex Pro"/>
-              </a:rPr>
-              <a:t>v0.3 keeps the most meaning (82%)</a:t>
-            </a:r>
-          </a:p>
-          <a:p>
-            <a:pPr algn="ctr"/>
-            <a:r>
-              <a:rPr sz="1050" b="1">
-                <a:solidFill>
-                  <a:srgbClr val="1A1A14"/>
-                </a:solidFill>
-                <a:latin typeface="Readex Pro"/>
-                <a:cs typeface="Readex Pro"/>
-                <a:ea typeface="Readex Pro"/>
-              </a:rPr>
-              <a:t>and still cuts 5.2 words</a:t>
-            </a:r>
-          </a:p>
-        </p:txBody>
-      </p:sp>
-      <p:sp>
-        <p:nvSpPr>
-          <p:cNvPr id="30" name="Rounded Rectangle 29"/>
-          <p:cNvSpPr/>
-          <p:nvPr/>
-        </p:nvSpPr>
-        <p:spPr>
-          <a:xfrm>
-            <a:off x="6464807" y="3794760"/>
-            <a:ext cx="2449068" cy="536448"/>
-          </a:xfrm>
-          <a:prstGeom prst="roundRect">
-            <a:avLst>
-              <a:gd name="adj" fmla="val 15340"/>
-            </a:avLst>
-          </a:prstGeom>
-          <a:solidFill>
-            <a:srgbClr val="EFE9D9"/>
-          </a:solidFill>
-          <a:ln w="15875">
-            <a:solidFill>
-              <a:srgbClr val="EFE9D9"/>
-            </a:solidFill>
-          </a:ln>
-          <a:effectLst/>
-        </p:spPr>
-        <p:style>
-          <a:lnRef idx="1">
-            <a:schemeClr val="accent1"/>
-          </a:lnRef>
-          <a:fillRef idx="3">
-            <a:schemeClr val="accent1"/>
-          </a:fillRef>
-          <a:effectRef idx="2">
-            <a:schemeClr val="accent1"/>
-          </a:effectRef>
-          <a:fontRef idx="minor">
-            <a:schemeClr val="lt1"/>
-          </a:fontRef>
-        </p:style>
-        <p:txBody>
-          <a:bodyPr rtlCol="0" anchor="ctr" wrap="square" lIns="109728" rIns="109728" tIns="0" bIns="0"/>
-          <a:lstStyle/>
-          <a:p>
-            <a:pPr algn="ctr"/>
-            <a:r>
-              <a:rPr sz="1200" b="0">
-                <a:solidFill>
-                  <a:srgbClr val="4A4842"/>
-                </a:solidFill>
-                <a:latin typeface="Readex Pro"/>
-                <a:cs typeface="Readex Pro"/>
-                <a:ea typeface="Readex Pro"/>
-              </a:rPr>
-              <a:t>the app's large model,</a:t>
-            </a:r>
-          </a:p>
-          <a:p>
-            <a:pPr algn="ctr"/>
-            <a:r>
-              <a:rPr sz="1200" b="0">
-                <a:solidFill>
-                  <a:srgbClr val="4A4842"/>
-                </a:solidFill>
-                <a:latin typeface="Readex Pro"/>
-                <a:cs typeface="Readex Pro"/>
-                <a:ea typeface="Readex Pro"/>
-              </a:rPr>
-              <a:t>four beams + safety net</a:t>
+              <a:t>decoded with four beams</a:t>
             </a:r>
           </a:p>
         </p:txBody>
@@ -19728,11 +19899,11 @@
         <p:spPr>
           <a:xfrm>
             <a:off x="1871535" y="5029200"/>
-            <a:ext cx="6159881" cy="357631"/>
+            <a:ext cx="6159881" cy="364236"/>
           </a:xfrm>
           <a:prstGeom prst="roundRect">
             <a:avLst>
-              <a:gd name="adj" fmla="val 23011"/>
+              <a:gd name="adj" fmla="val 22594"/>
             </a:avLst>
           </a:prstGeom>
           <a:solidFill>
@@ -20493,11 +20664,11 @@
         <p:spPr>
           <a:xfrm>
             <a:off x="1576578" y="4343400"/>
-            <a:ext cx="6749795" cy="341375"/>
+            <a:ext cx="6749795" cy="347472"/>
           </a:xfrm>
           <a:prstGeom prst="roundRect">
             <a:avLst>
-              <a:gd name="adj" fmla="val 24107"/>
+              <a:gd name="adj" fmla="val 23684"/>
             </a:avLst>
           </a:prstGeom>
           <a:solidFill>
@@ -20552,11 +20723,11 @@
         <p:spPr>
           <a:xfrm>
             <a:off x="3008248" y="4892040"/>
-            <a:ext cx="3886454" cy="357631"/>
+            <a:ext cx="3886454" cy="364236"/>
           </a:xfrm>
           <a:prstGeom prst="roundRect">
             <a:avLst>
-              <a:gd name="adj" fmla="val 23011"/>
+              <a:gd name="adj" fmla="val 22594"/>
             </a:avLst>
           </a:prstGeom>
           <a:solidFill>
@@ -20611,11 +20782,11 @@
         <p:spPr>
           <a:xfrm>
             <a:off x="990917" y="5440680"/>
-            <a:ext cx="7921116" cy="333248"/>
+            <a:ext cx="7921116" cy="339090"/>
           </a:xfrm>
           <a:prstGeom prst="roundRect">
             <a:avLst>
-              <a:gd name="adj" fmla="val 24695"/>
+              <a:gd name="adj" fmla="val 24269"/>
             </a:avLst>
           </a:prstGeom>
           <a:solidFill>
@@ -22483,11 +22654,11 @@
         <p:spPr>
           <a:xfrm>
             <a:off x="2318956" y="2606040"/>
-            <a:ext cx="5265039" cy="357631"/>
+            <a:ext cx="5265039" cy="364236"/>
           </a:xfrm>
           <a:prstGeom prst="roundRect">
             <a:avLst>
-              <a:gd name="adj" fmla="val 23011"/>
+              <a:gd name="adj" fmla="val 22594"/>
             </a:avLst>
           </a:prstGeom>
           <a:solidFill>
@@ -22542,11 +22713,11 @@
         <p:spPr>
           <a:xfrm>
             <a:off x="3236912" y="3172968"/>
-            <a:ext cx="3429127" cy="357631"/>
+            <a:ext cx="3429127" cy="364236"/>
           </a:xfrm>
           <a:prstGeom prst="roundRect">
             <a:avLst>
-              <a:gd name="adj" fmla="val 23011"/>
+              <a:gd name="adj" fmla="val 22594"/>
             </a:avLst>
           </a:prstGeom>
           <a:solidFill>
@@ -22601,11 +22772,11 @@
         <p:spPr>
           <a:xfrm>
             <a:off x="2642552" y="3739896"/>
-            <a:ext cx="4617847" cy="357631"/>
+            <a:ext cx="4617847" cy="364236"/>
           </a:xfrm>
           <a:prstGeom prst="roundRect">
             <a:avLst>
-              <a:gd name="adj" fmla="val 23011"/>
+              <a:gd name="adj" fmla="val 22594"/>
             </a:avLst>
           </a:prstGeom>
           <a:solidFill>
@@ -23358,11 +23529,11 @@
         <p:spPr>
           <a:xfrm>
             <a:off x="6034658" y="2788920"/>
-            <a:ext cx="2734818" cy="390144"/>
+            <a:ext cx="2734818" cy="397764"/>
           </a:xfrm>
           <a:prstGeom prst="roundRect">
             <a:avLst>
-              <a:gd name="adj" fmla="val 21093"/>
+              <a:gd name="adj" fmla="val 20689"/>
             </a:avLst>
           </a:prstGeom>
           <a:solidFill>
@@ -23417,11 +23588,11 @@
         <p:spPr>
           <a:xfrm>
             <a:off x="5963284" y="3429000"/>
-            <a:ext cx="2877566" cy="373888"/>
+            <a:ext cx="2877566" cy="381000"/>
           </a:xfrm>
           <a:prstGeom prst="roundRect">
             <a:avLst>
-              <a:gd name="adj" fmla="val 22010"/>
+              <a:gd name="adj" fmla="val 21599"/>
             </a:avLst>
           </a:prstGeom>
           <a:solidFill>
@@ -23476,11 +23647,11 @@
         <p:spPr>
           <a:xfrm>
             <a:off x="5662739" y="4069079"/>
-            <a:ext cx="3478657" cy="357631"/>
+            <a:ext cx="3478657" cy="364236"/>
           </a:xfrm>
           <a:prstGeom prst="roundRect">
             <a:avLst>
-              <a:gd name="adj" fmla="val 23011"/>
+              <a:gd name="adj" fmla="val 22594"/>
             </a:avLst>
           </a:prstGeom>
           <a:solidFill>
@@ -23898,11 +24069,11 @@
         <p:spPr>
           <a:xfrm>
             <a:off x="1501203" y="2743200"/>
-            <a:ext cx="2474849" cy="357631"/>
+            <a:ext cx="2474849" cy="364236"/>
           </a:xfrm>
           <a:prstGeom prst="roundRect">
             <a:avLst>
-              <a:gd name="adj" fmla="val 23011"/>
+              <a:gd name="adj" fmla="val 22594"/>
             </a:avLst>
           </a:prstGeom>
           <a:solidFill>
@@ -23957,11 +24128,11 @@
         <p:spPr>
           <a:xfrm>
             <a:off x="1388109" y="3520440"/>
-            <a:ext cx="2701036" cy="357631"/>
+            <a:ext cx="2701036" cy="364236"/>
           </a:xfrm>
           <a:prstGeom prst="roundRect">
             <a:avLst>
-              <a:gd name="adj" fmla="val 23011"/>
+              <a:gd name="adj" fmla="val 22594"/>
             </a:avLst>
           </a:prstGeom>
           <a:solidFill>
@@ -24016,11 +24187,11 @@
         <p:spPr>
           <a:xfrm>
             <a:off x="827881" y="4297680"/>
-            <a:ext cx="3821493" cy="333248"/>
+            <a:ext cx="3821493" cy="339090"/>
           </a:xfrm>
           <a:prstGeom prst="roundRect">
             <a:avLst>
-              <a:gd name="adj" fmla="val 24695"/>
+              <a:gd name="adj" fmla="val 24269"/>
             </a:avLst>
           </a:prstGeom>
           <a:solidFill>
@@ -24160,11 +24331,11 @@
         <p:spPr>
           <a:xfrm>
             <a:off x="5931852" y="2743200"/>
-            <a:ext cx="2940431" cy="357631"/>
+            <a:ext cx="2940431" cy="364236"/>
           </a:xfrm>
           <a:prstGeom prst="roundRect">
             <a:avLst>
-              <a:gd name="adj" fmla="val 23011"/>
+              <a:gd name="adj" fmla="val 22594"/>
             </a:avLst>
           </a:prstGeom>
           <a:solidFill>
@@ -24219,11 +24390,11 @@
         <p:spPr>
           <a:xfrm>
             <a:off x="5823711" y="3520440"/>
-            <a:ext cx="3156712" cy="357631"/>
+            <a:ext cx="3156712" cy="364236"/>
           </a:xfrm>
           <a:prstGeom prst="roundRect">
             <a:avLst>
-              <a:gd name="adj" fmla="val 23011"/>
+              <a:gd name="adj" fmla="val 22594"/>
             </a:avLst>
           </a:prstGeom>
           <a:solidFill>
@@ -24278,11 +24449,11 @@
         <p:spPr>
           <a:xfrm>
             <a:off x="5684202" y="4297680"/>
-            <a:ext cx="3435731" cy="357631"/>
+            <a:ext cx="3435731" cy="364236"/>
           </a:xfrm>
           <a:prstGeom prst="roundRect">
             <a:avLst>
-              <a:gd name="adj" fmla="val 23011"/>
+              <a:gd name="adj" fmla="val 22594"/>
             </a:avLst>
           </a:prstGeom>
           <a:solidFill>
@@ -24980,11 +25151,11 @@
         <p:spPr>
           <a:xfrm>
             <a:off x="566928" y="3401568"/>
-            <a:ext cx="2659761" cy="357631"/>
+            <a:ext cx="2659761" cy="364236"/>
           </a:xfrm>
           <a:prstGeom prst="roundRect">
             <a:avLst>
-              <a:gd name="adj" fmla="val 23011"/>
+              <a:gd name="adj" fmla="val 22594"/>
             </a:avLst>
           </a:prstGeom>
           <a:solidFill>
@@ -25039,11 +25210,11 @@
         <p:spPr>
           <a:xfrm>
             <a:off x="566928" y="3877056"/>
-            <a:ext cx="4485767" cy="357631"/>
+            <a:ext cx="4485767" cy="364236"/>
           </a:xfrm>
           <a:prstGeom prst="roundRect">
             <a:avLst>
-              <a:gd name="adj" fmla="val 23011"/>
+              <a:gd name="adj" fmla="val 22594"/>
             </a:avLst>
           </a:prstGeom>
           <a:solidFill>
@@ -25098,11 +25269,11 @@
         <p:spPr>
           <a:xfrm>
             <a:off x="566928" y="4352544"/>
-            <a:ext cx="3843528" cy="357631"/>
+            <a:ext cx="3843528" cy="364236"/>
           </a:xfrm>
           <a:prstGeom prst="roundRect">
             <a:avLst>
-              <a:gd name="adj" fmla="val 23011"/>
+              <a:gd name="adj" fmla="val 22594"/>
             </a:avLst>
           </a:prstGeom>
           <a:solidFill>
@@ -25157,11 +25328,11 @@
         <p:spPr>
           <a:xfrm>
             <a:off x="566928" y="5029200"/>
-            <a:ext cx="7021067" cy="341375"/>
+            <a:ext cx="7021067" cy="347472"/>
           </a:xfrm>
           <a:prstGeom prst="roundRect">
             <a:avLst>
-              <a:gd name="adj" fmla="val 24107"/>
+              <a:gd name="adj" fmla="val 23684"/>
             </a:avLst>
           </a:prstGeom>
           <a:solidFill>
@@ -26881,11 +27052,11 @@
         <p:spPr>
           <a:xfrm>
             <a:off x="5596128" y="2331720"/>
-            <a:ext cx="2827782" cy="601472"/>
+            <a:ext cx="2827782" cy="615696"/>
           </a:xfrm>
           <a:prstGeom prst="roundRect">
             <a:avLst>
-              <a:gd name="adj" fmla="val 13682"/>
+              <a:gd name="adj" fmla="val 13366"/>
             </a:avLst>
           </a:prstGeom>
           <a:solidFill>
@@ -26954,11 +27125,11 @@
         <p:spPr>
           <a:xfrm>
             <a:off x="1920493" y="3977639"/>
-            <a:ext cx="6061964" cy="373888"/>
+            <a:ext cx="6061964" cy="381000"/>
           </a:xfrm>
           <a:prstGeom prst="roundRect">
             <a:avLst>
-              <a:gd name="adj" fmla="val 22010"/>
+              <a:gd name="adj" fmla="val 21599"/>
             </a:avLst>
           </a:prstGeom>
           <a:solidFill>

</xml_diff>

<commit_message>
Submission deck: uniform question chips and text alignment
Match pill sizes inside the measuring cards, align related labels
consistently, and point the number gate at refs that still exist.
</commit_message>
<xml_diff>
--- a/deliverables/04_presentation/Bayan_Submission.pptx
+++ b/deliverables/04_presentation/Bayan_Submission.pptx
@@ -14781,12 +14781,12 @@
         </p:nvSpPr>
         <p:spPr>
           <a:xfrm>
-            <a:off x="566928" y="2926080"/>
-            <a:ext cx="4434840" cy="3063240"/>
+            <a:off x="566928" y="2834640"/>
+            <a:ext cx="4434840" cy="3246120"/>
           </a:xfrm>
           <a:prstGeom prst="roundRect">
             <a:avLst>
-              <a:gd name="adj" fmla="val 4776"/>
+              <a:gd name="adj" fmla="val 4507"/>
             </a:avLst>
           </a:prstGeom>
           <a:solidFill>
@@ -14829,7 +14829,7 @@
         </p:nvSpPr>
         <p:spPr>
           <a:xfrm>
-            <a:off x="566928" y="3090672"/>
+            <a:off x="566928" y="2999232"/>
             <a:ext cx="4434840" cy="347472"/>
           </a:xfrm>
           <a:prstGeom prst="rect">
@@ -14866,12 +14866,12 @@
         </p:nvSpPr>
         <p:spPr>
           <a:xfrm>
-            <a:off x="795528" y="3584448"/>
-            <a:ext cx="3977639" cy="442468"/>
+            <a:off x="818387" y="3493008"/>
+            <a:ext cx="3931920" cy="384048"/>
           </a:xfrm>
           <a:prstGeom prst="roundRect">
             <a:avLst>
-              <a:gd name="adj" fmla="val 18599"/>
+              <a:gd name="adj" fmla="val 21428"/>
             </a:avLst>
           </a:prstGeom>
           <a:solidFill>
@@ -14925,12 +14925,12 @@
         </p:nvSpPr>
         <p:spPr>
           <a:xfrm>
-            <a:off x="1988058" y="4173220"/>
-            <a:ext cx="1592579" cy="514858"/>
+            <a:off x="818387" y="4005072"/>
+            <a:ext cx="3931920" cy="384048"/>
           </a:xfrm>
           <a:prstGeom prst="roundRect">
             <a:avLst>
-              <a:gd name="adj" fmla="val 15984"/>
+              <a:gd name="adj" fmla="val 21428"/>
             </a:avLst>
           </a:prstGeom>
           <a:solidFill>
@@ -14963,7 +14963,7 @@
           <a:p>
             <a:pPr algn="ctr"/>
             <a:r>
-              <a:rPr sz="1300" b="0">
+              <a:rPr sz="1000" b="0">
                 <a:solidFill>
                   <a:srgbClr val="4A4842"/>
                 </a:solidFill>
@@ -14984,12 +14984,12 @@
         </p:nvSpPr>
         <p:spPr>
           <a:xfrm>
-            <a:off x="1942655" y="4834382"/>
-            <a:ext cx="1683384" cy="514858"/>
+            <a:off x="818387" y="4517136"/>
+            <a:ext cx="3931920" cy="384048"/>
           </a:xfrm>
           <a:prstGeom prst="roundRect">
             <a:avLst>
-              <a:gd name="adj" fmla="val 15984"/>
+              <a:gd name="adj" fmla="val 21428"/>
             </a:avLst>
           </a:prstGeom>
           <a:solidFill>
@@ -15022,7 +15022,7 @@
           <a:p>
             <a:pPr algn="ctr"/>
             <a:r>
-              <a:rPr sz="1300" b="0">
+              <a:rPr sz="1000" b="0">
                 <a:solidFill>
                   <a:srgbClr val="4A4842"/>
                 </a:solidFill>
@@ -15043,12 +15043,12 @@
         </p:nvSpPr>
         <p:spPr>
           <a:xfrm>
-            <a:off x="2010346" y="5495544"/>
-            <a:ext cx="1548003" cy="514858"/>
+            <a:off x="818387" y="5029200"/>
+            <a:ext cx="3931920" cy="384048"/>
           </a:xfrm>
           <a:prstGeom prst="roundRect">
             <a:avLst>
-              <a:gd name="adj" fmla="val 15984"/>
+              <a:gd name="adj" fmla="val 21428"/>
             </a:avLst>
           </a:prstGeom>
           <a:solidFill>
@@ -15081,7 +15081,7 @@
           <a:p>
             <a:pPr algn="ctr"/>
             <a:r>
-              <a:rPr sz="1300" b="0">
+              <a:rPr sz="1000" b="0">
                 <a:solidFill>
                   <a:srgbClr val="4A4842"/>
                 </a:solidFill>
@@ -15102,12 +15102,12 @@
         </p:nvSpPr>
         <p:spPr>
           <a:xfrm>
-            <a:off x="5321807" y="2926080"/>
-            <a:ext cx="4434840" cy="3063240"/>
+            <a:off x="5321807" y="2834640"/>
+            <a:ext cx="4434840" cy="3246120"/>
           </a:xfrm>
           <a:prstGeom prst="roundRect">
             <a:avLst>
-              <a:gd name="adj" fmla="val 4776"/>
+              <a:gd name="adj" fmla="val 4507"/>
             </a:avLst>
           </a:prstGeom>
           <a:solidFill>
@@ -15150,7 +15150,7 @@
         </p:nvSpPr>
         <p:spPr>
           <a:xfrm>
-            <a:off x="5321807" y="3090672"/>
+            <a:off x="5321807" y="2999232"/>
             <a:ext cx="4434840" cy="347472"/>
           </a:xfrm>
           <a:prstGeom prst="rect">
@@ -15187,12 +15187,12 @@
         </p:nvSpPr>
         <p:spPr>
           <a:xfrm>
-            <a:off x="6618287" y="3584448"/>
-            <a:ext cx="1841881" cy="514858"/>
+            <a:off x="5573267" y="3493008"/>
+            <a:ext cx="3931920" cy="384048"/>
           </a:xfrm>
           <a:prstGeom prst="roundRect">
             <a:avLst>
-              <a:gd name="adj" fmla="val 15984"/>
+              <a:gd name="adj" fmla="val 21428"/>
             </a:avLst>
           </a:prstGeom>
           <a:solidFill>
@@ -15225,7 +15225,7 @@
           <a:p>
             <a:pPr algn="ctr"/>
             <a:r>
-              <a:rPr sz="1300" b="0">
+              <a:rPr sz="1250" b="0">
                 <a:solidFill>
                   <a:srgbClr val="4A4842"/>
                 </a:solidFill>
@@ -15246,12 +15246,12 @@
         </p:nvSpPr>
         <p:spPr>
           <a:xfrm>
-            <a:off x="6879145" y="4245610"/>
-            <a:ext cx="1320165" cy="514858"/>
+            <a:off x="5573267" y="4005072"/>
+            <a:ext cx="3931920" cy="384048"/>
           </a:xfrm>
           <a:prstGeom prst="roundRect">
             <a:avLst>
-              <a:gd name="adj" fmla="val 15984"/>
+              <a:gd name="adj" fmla="val 21428"/>
             </a:avLst>
           </a:prstGeom>
           <a:solidFill>
@@ -15284,7 +15284,7 @@
           <a:p>
             <a:pPr algn="ctr"/>
             <a:r>
-              <a:rPr sz="1300" b="0">
+              <a:rPr sz="1250" b="0">
                 <a:solidFill>
                   <a:srgbClr val="4A4842"/>
                 </a:solidFill>
@@ -15305,12 +15305,12 @@
         </p:nvSpPr>
         <p:spPr>
           <a:xfrm>
-            <a:off x="6629019" y="4906772"/>
-            <a:ext cx="1820417" cy="514858"/>
+            <a:off x="5573267" y="4517136"/>
+            <a:ext cx="3931920" cy="384048"/>
           </a:xfrm>
           <a:prstGeom prst="roundRect">
             <a:avLst>
-              <a:gd name="adj" fmla="val 15984"/>
+              <a:gd name="adj" fmla="val 21428"/>
             </a:avLst>
           </a:prstGeom>
           <a:solidFill>
@@ -15343,7 +15343,7 @@
           <a:p>
             <a:pPr algn="ctr"/>
             <a:r>
-              <a:rPr sz="1300" b="0">
+              <a:rPr sz="1250" b="0">
                 <a:solidFill>
                   <a:srgbClr val="4A4842"/>
                 </a:solidFill>
@@ -15364,45 +15364,8 @@
         </p:nvSpPr>
         <p:spPr>
           <a:xfrm>
-            <a:off x="5504688" y="5550408"/>
-            <a:ext cx="4069079" cy="347472"/>
-          </a:xfrm>
-          <a:prstGeom prst="rect">
-            <a:avLst/>
-          </a:prstGeom>
-          <a:noFill/>
-        </p:spPr>
-        <p:txBody>
-          <a:bodyPr wrap="square" lIns="0" rIns="0" tIns="0" bIns="0" anchor="ctr">
-            <a:spAutoFit/>
-          </a:bodyPr>
-          <a:lstStyle/>
-          <a:p>
-            <a:pPr algn="ctr"/>
-            <a:r>
-              <a:rPr sz="1050" b="0">
-                <a:solidFill>
-                  <a:srgbClr val="6F6B5E"/>
-                </a:solidFill>
-                <a:latin typeface="Readex Pro"/>
-                <a:cs typeface="Readex Pro"/>
-                <a:ea typeface="Readex Pro"/>
-              </a:rPr>
-              <a:t>people barely agree on these: never used to decide</a:t>
-            </a:r>
-          </a:p>
-        </p:txBody>
-      </p:sp>
-      <p:sp>
-        <p:nvSpPr>
-          <p:cNvPr id="28" name="TextBox 27"/>
-          <p:cNvSpPr txBox="1"/>
-          <p:nvPr/>
-        </p:nvSpPr>
-        <p:spPr>
-          <a:xfrm>
-            <a:off x="5504688" y="5550408"/>
-            <a:ext cx="4069079" cy="347472"/>
+            <a:off x="5504688" y="5696712"/>
+            <a:ext cx="4069079" cy="292608"/>
           </a:xfrm>
           <a:prstGeom prst="rect">
             <a:avLst/>
@@ -21881,7 +21844,7 @@
         </p:nvSpPr>
         <p:spPr>
           <a:xfrm>
-            <a:off x="886968" y="3639312"/>
+            <a:off x="1069848" y="3639312"/>
             <a:ext cx="45720" cy="146304"/>
           </a:xfrm>
           <a:prstGeom prst="rect">
@@ -21925,7 +21888,7 @@
         </p:nvSpPr>
         <p:spPr>
           <a:xfrm>
-            <a:off x="996695" y="3611880"/>
+            <a:off x="1179576" y="3611880"/>
             <a:ext cx="5943600" cy="201168"/>
           </a:xfrm>
           <a:prstGeom prst="rect">
@@ -21939,7 +21902,7 @@
           </a:bodyPr>
           <a:lstStyle/>
           <a:p>
-            <a:pPr algn="l"/>
+            <a:pPr algn="ctr"/>
             <a:r>
               <a:rPr sz="1050" b="0">
                 <a:solidFill>

</xml_diff>

<commit_message>
Both decks: SIC Enabling People closer and report-alignment fixes
Add the template's closing slide to the presenting HTML and the
submission pptx, point the scatter at the report's 82%/5.2, bridge the
as-trained vs shipped scores, and soften the scope chip for tashkeel.
</commit_message>
<xml_diff>
--- a/deliverables/04_presentation/Bayan_Submission.pptx
+++ b/deliverables/04_presentation/Bayan_Submission.pptx
@@ -28,6 +28,7 @@
     <p:sldId id="273" r:id="rId37"/>
     <p:sldId id="274" r:id="rId38"/>
     <p:sldId id="275" r:id="rId39"/>
+    <p:sldId id="276" r:id="rId40"/>
   </p:sldIdLst>
   <p:sldSz cx="9902825" cy="6858000"/>
   <p:notesSz cx="6858000" cy="9144000"/>
@@ -1753,7 +1754,7 @@
           </a:p>
           <a:p>
             <a:r>
-              <a:t>Shorter clauses help the weakest readers most. So Bayan reduces reading load: long clauses, hard words. Not decoding, and we don't yet claim it helps readers with dyslexia.</a:t>
+              <a:t>Shorter clauses help the weakest readers most. So Bayan reduces reading load: long clauses, hard words. Tashkeel is a setting in the app, and we don't yet claim it helps readers with dyslexia.</a:t>
             </a:r>
           </a:p>
         </p:txBody>
@@ -1937,7 +1938,7 @@
           </a:p>
           <a:p>
             <a:r>
-              <a:t>Shorter clauses help the weakest readers most. So Bayan reduces reading load: long clauses, hard words. Not decoding, and we don't yet claim it helps readers with dyslexia.</a:t>
+              <a:t>Shorter clauses help the weakest readers most. So Bayan reduces reading load: long clauses, hard words. Tashkeel is a setting in the app, and we don't yet claim it helps readers with dyslexia.</a:t>
             </a:r>
           </a:p>
         </p:txBody>
@@ -13959,7 +13960,7 @@
         <p:spPr>
           <a:xfrm>
             <a:off x="566928" y="4892040"/>
-            <a:ext cx="6126480" cy="256032"/>
+            <a:ext cx="6126480" cy="384048"/>
           </a:xfrm>
           <a:prstGeom prst="rect">
             <a:avLst/>
@@ -13982,7 +13983,7 @@
                 <a:cs typeface="Readex Pro"/>
                 <a:ea typeface="Readex Pro"/>
               </a:rPr>
-              <a:t>test core items, as trained · words cut = longest clause, before minus after</a:t>
+              <a:t>test core items, as trained (float, greedy) · the shipped app model with four beams is on the results slide</a:t>
             </a:r>
           </a:p>
         </p:txBody>
@@ -14781,12 +14782,12 @@
         </p:nvSpPr>
         <p:spPr>
           <a:xfrm>
-            <a:off x="566928" y="2834640"/>
-            <a:ext cx="4434840" cy="3246120"/>
+            <a:off x="566928" y="2651760"/>
+            <a:ext cx="4434840" cy="3611880"/>
           </a:xfrm>
           <a:prstGeom prst="roundRect">
             <a:avLst>
-              <a:gd name="adj" fmla="val 4507"/>
+              <a:gd name="adj" fmla="val 4050"/>
             </a:avLst>
           </a:prstGeom>
           <a:solidFill>
@@ -14829,8 +14830,8 @@
         </p:nvSpPr>
         <p:spPr>
           <a:xfrm>
-            <a:off x="566928" y="2999232"/>
-            <a:ext cx="4434840" cy="347472"/>
+            <a:off x="566928" y="2798064"/>
+            <a:ext cx="4434840" cy="329184"/>
           </a:xfrm>
           <a:prstGeom prst="rect">
             <a:avLst/>
@@ -14845,7 +14846,7 @@
           <a:p>
             <a:pPr algn="ctr"/>
             <a:r>
-              <a:rPr sz="1600" b="1">
+              <a:rPr sz="1500" b="1">
                 <a:solidFill>
                   <a:srgbClr val="8A5E35"/>
                 </a:solidFill>
@@ -14866,12 +14867,12 @@
         </p:nvSpPr>
         <p:spPr>
           <a:xfrm>
-            <a:off x="818387" y="3493008"/>
-            <a:ext cx="3931920" cy="384048"/>
+            <a:off x="694944" y="3218688"/>
+            <a:ext cx="4178807" cy="530352"/>
           </a:xfrm>
           <a:prstGeom prst="roundRect">
             <a:avLst>
-              <a:gd name="adj" fmla="val 21428"/>
+              <a:gd name="adj" fmla="val 15517"/>
             </a:avLst>
           </a:prstGeom>
           <a:solidFill>
@@ -14904,7 +14905,7 @@
           <a:p>
             <a:pPr algn="ctr"/>
             <a:r>
-              <a:rPr sz="1000" b="1">
+              <a:rPr sz="1050" b="1">
                 <a:solidFill>
                   <a:srgbClr val="1A1A14"/>
                 </a:solidFill>
@@ -14925,12 +14926,12 @@
         </p:nvSpPr>
         <p:spPr>
           <a:xfrm>
-            <a:off x="818387" y="4005072"/>
-            <a:ext cx="3931920" cy="384048"/>
+            <a:off x="694944" y="3858768"/>
+            <a:ext cx="4178807" cy="530352"/>
           </a:xfrm>
           <a:prstGeom prst="roundRect">
             <a:avLst>
-              <a:gd name="adj" fmla="val 21428"/>
+              <a:gd name="adj" fmla="val 15517"/>
             </a:avLst>
           </a:prstGeom>
           <a:solidFill>
@@ -14963,7 +14964,7 @@
           <a:p>
             <a:pPr algn="ctr"/>
             <a:r>
-              <a:rPr sz="1000" b="0">
+              <a:rPr sz="1050" b="0">
                 <a:solidFill>
                   <a:srgbClr val="4A4842"/>
                 </a:solidFill>
@@ -14984,12 +14985,12 @@
         </p:nvSpPr>
         <p:spPr>
           <a:xfrm>
-            <a:off x="818387" y="4517136"/>
-            <a:ext cx="3931920" cy="384048"/>
+            <a:off x="694944" y="4498848"/>
+            <a:ext cx="4178807" cy="530352"/>
           </a:xfrm>
           <a:prstGeom prst="roundRect">
             <a:avLst>
-              <a:gd name="adj" fmla="val 21428"/>
+              <a:gd name="adj" fmla="val 15517"/>
             </a:avLst>
           </a:prstGeom>
           <a:solidFill>
@@ -15022,7 +15023,7 @@
           <a:p>
             <a:pPr algn="ctr"/>
             <a:r>
-              <a:rPr sz="1000" b="0">
+              <a:rPr sz="1050" b="0">
                 <a:solidFill>
                   <a:srgbClr val="4A4842"/>
                 </a:solidFill>
@@ -15043,12 +15044,12 @@
         </p:nvSpPr>
         <p:spPr>
           <a:xfrm>
-            <a:off x="818387" y="5029200"/>
-            <a:ext cx="3931920" cy="384048"/>
+            <a:off x="694944" y="5138928"/>
+            <a:ext cx="4178807" cy="530352"/>
           </a:xfrm>
           <a:prstGeom prst="roundRect">
             <a:avLst>
-              <a:gd name="adj" fmla="val 21428"/>
+              <a:gd name="adj" fmla="val 15517"/>
             </a:avLst>
           </a:prstGeom>
           <a:solidFill>
@@ -15081,7 +15082,7 @@
           <a:p>
             <a:pPr algn="ctr"/>
             <a:r>
-              <a:rPr sz="1000" b="0">
+              <a:rPr sz="1050" b="0">
                 <a:solidFill>
                   <a:srgbClr val="4A4842"/>
                 </a:solidFill>
@@ -15102,12 +15103,12 @@
         </p:nvSpPr>
         <p:spPr>
           <a:xfrm>
-            <a:off x="5321807" y="2834640"/>
-            <a:ext cx="4434840" cy="3246120"/>
+            <a:off x="5321807" y="2651760"/>
+            <a:ext cx="4434840" cy="3611880"/>
           </a:xfrm>
           <a:prstGeom prst="roundRect">
             <a:avLst>
-              <a:gd name="adj" fmla="val 4507"/>
+              <a:gd name="adj" fmla="val 4050"/>
             </a:avLst>
           </a:prstGeom>
           <a:solidFill>
@@ -15150,8 +15151,8 @@
         </p:nvSpPr>
         <p:spPr>
           <a:xfrm>
-            <a:off x="5321807" y="2999232"/>
-            <a:ext cx="4434840" cy="347472"/>
+            <a:off x="5321807" y="2798064"/>
+            <a:ext cx="4434840" cy="329184"/>
           </a:xfrm>
           <a:prstGeom prst="rect">
             <a:avLst/>
@@ -15166,7 +15167,7 @@
           <a:p>
             <a:pPr algn="ctr"/>
             <a:r>
-              <a:rPr sz="1600" b="1">
+              <a:rPr sz="1500" b="1">
                 <a:solidFill>
                   <a:srgbClr val="8A5E35"/>
                 </a:solidFill>
@@ -15187,12 +15188,12 @@
         </p:nvSpPr>
         <p:spPr>
           <a:xfrm>
-            <a:off x="5573267" y="3493008"/>
-            <a:ext cx="3931920" cy="384048"/>
+            <a:off x="5449823" y="3218688"/>
+            <a:ext cx="4178807" cy="530352"/>
           </a:xfrm>
           <a:prstGeom prst="roundRect">
             <a:avLst>
-              <a:gd name="adj" fmla="val 21428"/>
+              <a:gd name="adj" fmla="val 15517"/>
             </a:avLst>
           </a:prstGeom>
           <a:solidFill>
@@ -15225,7 +15226,7 @@
           <a:p>
             <a:pPr algn="ctr"/>
             <a:r>
-              <a:rPr sz="1250" b="0">
+              <a:rPr sz="1050" b="0">
                 <a:solidFill>
                   <a:srgbClr val="4A4842"/>
                 </a:solidFill>
@@ -15246,12 +15247,12 @@
         </p:nvSpPr>
         <p:spPr>
           <a:xfrm>
-            <a:off x="5573267" y="4005072"/>
-            <a:ext cx="3931920" cy="384048"/>
+            <a:off x="5449823" y="3858768"/>
+            <a:ext cx="4178807" cy="530352"/>
           </a:xfrm>
           <a:prstGeom prst="roundRect">
             <a:avLst>
-              <a:gd name="adj" fmla="val 21428"/>
+              <a:gd name="adj" fmla="val 15517"/>
             </a:avLst>
           </a:prstGeom>
           <a:solidFill>
@@ -15284,7 +15285,7 @@
           <a:p>
             <a:pPr algn="ctr"/>
             <a:r>
-              <a:rPr sz="1250" b="0">
+              <a:rPr sz="1050" b="0">
                 <a:solidFill>
                   <a:srgbClr val="4A4842"/>
                 </a:solidFill>
@@ -15305,12 +15306,12 @@
         </p:nvSpPr>
         <p:spPr>
           <a:xfrm>
-            <a:off x="5573267" y="4517136"/>
-            <a:ext cx="3931920" cy="384048"/>
+            <a:off x="5449823" y="4498848"/>
+            <a:ext cx="4178807" cy="530352"/>
           </a:xfrm>
           <a:prstGeom prst="roundRect">
             <a:avLst>
-              <a:gd name="adj" fmla="val 21428"/>
+              <a:gd name="adj" fmla="val 15517"/>
             </a:avLst>
           </a:prstGeom>
           <a:solidFill>
@@ -15343,7 +15344,7 @@
           <a:p>
             <a:pPr algn="ctr"/>
             <a:r>
-              <a:rPr sz="1250" b="0">
+              <a:rPr sz="1050" b="0">
                 <a:solidFill>
                   <a:srgbClr val="4A4842"/>
                 </a:solidFill>
@@ -15364,8 +15365,8 @@
         </p:nvSpPr>
         <p:spPr>
           <a:xfrm>
-            <a:off x="5504688" y="5696712"/>
-            <a:ext cx="4069079" cy="292608"/>
+            <a:off x="5504688" y="5934455"/>
+            <a:ext cx="4069079" cy="256032"/>
           </a:xfrm>
           <a:prstGeom prst="rect">
             <a:avLst/>
@@ -15380,7 +15381,7 @@
           <a:p>
             <a:pPr algn="ctr"/>
             <a:r>
-              <a:rPr sz="1050" b="0">
+              <a:rPr sz="950" b="0">
                 <a:solidFill>
                   <a:srgbClr val="6F6B5E"/>
                 </a:solidFill>
@@ -17504,8 +17505,8 @@
         </p:nvCxnSpPr>
         <p:spPr>
           <a:xfrm>
-            <a:off x="2148840" y="5120640"/>
-            <a:ext cx="4617720" cy="0"/>
+            <a:off x="2331720" y="5029200"/>
+            <a:ext cx="4434839" cy="0"/>
           </a:xfrm>
           <a:prstGeom prst="line">
             <a:avLst/>
@@ -17539,8 +17540,8 @@
         </p:nvCxnSpPr>
         <p:spPr>
           <a:xfrm>
-            <a:off x="2148840" y="1874519"/>
-            <a:ext cx="0" cy="3246121"/>
+            <a:off x="2331720" y="1783080"/>
+            <a:ext cx="0" cy="3246120"/>
           </a:xfrm>
           <a:prstGeom prst="line">
             <a:avLst/>
@@ -17574,8 +17575,8 @@
         </p:nvSpPr>
         <p:spPr>
           <a:xfrm>
-            <a:off x="2148840" y="5230368"/>
-            <a:ext cx="4617720" cy="256032"/>
+            <a:off x="2331720" y="5138928"/>
+            <a:ext cx="4434840" cy="256032"/>
           </a:xfrm>
           <a:prstGeom prst="rect">
             <a:avLst/>
@@ -17611,8 +17612,8 @@
         </p:nvSpPr>
         <p:spPr>
           <a:xfrm rot="16200000">
-            <a:off x="1673352" y="3369563"/>
-            <a:ext cx="3291840" cy="256032"/>
+            <a:off x="393191" y="3278123"/>
+            <a:ext cx="3108960" cy="256032"/>
           </a:xfrm>
           <a:prstGeom prst="rect">
             <a:avLst/>
@@ -17627,7 +17628,7 @@
           <a:p>
             <a:pPr algn="ctr"/>
             <a:r>
-              <a:rPr sz="1150" b="0">
+              <a:rPr sz="1100" b="0">
                 <a:solidFill>
                   <a:srgbClr val="6F6B5E"/>
                 </a:solidFill>
@@ -17648,7 +17649,7 @@
         </p:nvSpPr>
         <p:spPr>
           <a:xfrm>
-            <a:off x="6353555" y="4777963"/>
+            <a:off x="6365747" y="4686523"/>
             <a:ext cx="210312" cy="210312"/>
           </a:xfrm>
           <a:prstGeom prst="ellipse">
@@ -17692,7 +17693,7 @@
         </p:nvSpPr>
         <p:spPr>
           <a:xfrm>
-            <a:off x="5836920" y="4467067"/>
+            <a:off x="5849112" y="4375627"/>
             <a:ext cx="1243584" cy="237744"/>
           </a:xfrm>
           <a:prstGeom prst="rect">
@@ -17729,7 +17730,7 @@
         </p:nvSpPr>
         <p:spPr>
           <a:xfrm>
-            <a:off x="4875885" y="4777963"/>
+            <a:off x="4946599" y="4686523"/>
             <a:ext cx="210312" cy="210312"/>
           </a:xfrm>
           <a:prstGeom prst="ellipse">
@@ -17773,7 +17774,7 @@
         </p:nvSpPr>
         <p:spPr>
           <a:xfrm>
-            <a:off x="4788255" y="4467067"/>
+            <a:off x="4858969" y="4969987"/>
             <a:ext cx="385572" cy="237744"/>
           </a:xfrm>
           <a:prstGeom prst="rect">
@@ -17810,7 +17811,7 @@
         </p:nvSpPr>
         <p:spPr>
           <a:xfrm>
-            <a:off x="5035966" y="4025813"/>
+            <a:off x="5100340" y="3934373"/>
             <a:ext cx="210312" cy="210312"/>
           </a:xfrm>
           <a:prstGeom prst="ellipse">
@@ -17854,7 +17855,7 @@
         </p:nvSpPr>
         <p:spPr>
           <a:xfrm>
-            <a:off x="4507900" y="3714917"/>
+            <a:off x="4572274" y="4217837"/>
             <a:ext cx="1266443" cy="237744"/>
           </a:xfrm>
           <a:prstGeom prst="rect">
@@ -17891,7 +17892,7 @@
         </p:nvSpPr>
         <p:spPr>
           <a:xfrm>
-            <a:off x="4401799" y="2996555"/>
+            <a:off x="4491288" y="2905115"/>
             <a:ext cx="210312" cy="210312"/>
           </a:xfrm>
           <a:prstGeom prst="ellipse">
@@ -17935,7 +17936,7 @@
         </p:nvSpPr>
         <p:spPr>
           <a:xfrm>
-            <a:off x="3257783" y="2982839"/>
+            <a:off x="3347272" y="2891399"/>
             <a:ext cx="1052576" cy="237744"/>
           </a:xfrm>
           <a:prstGeom prst="rect">
@@ -17972,7 +17973,7 @@
         </p:nvSpPr>
         <p:spPr>
           <a:xfrm>
-            <a:off x="3859987" y="2283992"/>
+            <a:off x="3970934" y="2192552"/>
             <a:ext cx="210312" cy="210312"/>
           </a:xfrm>
           <a:prstGeom prst="ellipse">
@@ -18016,7 +18017,7 @@
         </p:nvSpPr>
         <p:spPr>
           <a:xfrm>
-            <a:off x="3554107" y="2567456"/>
+            <a:off x="4290974" y="2178836"/>
             <a:ext cx="822070" cy="237744"/>
           </a:xfrm>
           <a:prstGeom prst="rect">
@@ -18053,7 +18054,7 @@
         </p:nvSpPr>
         <p:spPr>
           <a:xfrm>
-            <a:off x="3361273" y="2838208"/>
+            <a:off x="3491971" y="2746768"/>
             <a:ext cx="210312" cy="210312"/>
           </a:xfrm>
           <a:prstGeom prst="ellipse">
@@ -18097,7 +18098,7 @@
         </p:nvSpPr>
         <p:spPr>
           <a:xfrm>
-            <a:off x="2738973" y="3121672"/>
+            <a:off x="2869671" y="2435872"/>
             <a:ext cx="1454912" cy="237744"/>
           </a:xfrm>
           <a:prstGeom prst="rect">
@@ -18134,7 +18135,7 @@
         </p:nvSpPr>
         <p:spPr>
           <a:xfrm>
-            <a:off x="2665536" y="2125645"/>
+            <a:off x="2823789" y="2034205"/>
             <a:ext cx="210312" cy="210312"/>
           </a:xfrm>
           <a:prstGeom prst="ellipse">
@@ -18178,7 +18179,7 @@
         </p:nvSpPr>
         <p:spPr>
           <a:xfrm>
-            <a:off x="2985576" y="2111929"/>
+            <a:off x="2316741" y="1723309"/>
             <a:ext cx="1224407" cy="237744"/>
           </a:xfrm>
           <a:prstGeom prst="rect">
@@ -18215,7 +18216,7 @@
         </p:nvSpPr>
         <p:spPr>
           <a:xfrm>
-            <a:off x="5094427" y="2568571"/>
+            <a:off x="5150510" y="2477131"/>
             <a:ext cx="512064" cy="512064"/>
           </a:xfrm>
           <a:prstGeom prst="ellipse">
@@ -18259,7 +18260,7 @@
         </p:nvSpPr>
         <p:spPr>
           <a:xfrm>
-            <a:off x="5204155" y="2678299"/>
+            <a:off x="5260238" y="2586859"/>
             <a:ext cx="292608" cy="292608"/>
           </a:xfrm>
           <a:prstGeom prst="ellipse">
@@ -18303,7 +18304,7 @@
         </p:nvSpPr>
         <p:spPr>
           <a:xfrm>
-            <a:off x="5606491" y="2705731"/>
+            <a:off x="5662574" y="2614291"/>
             <a:ext cx="1364361" cy="237744"/>
           </a:xfrm>
           <a:prstGeom prst="rect">
@@ -18340,7 +18341,7 @@
         </p:nvSpPr>
         <p:spPr>
           <a:xfrm>
-            <a:off x="2240280" y="5605272"/>
+            <a:off x="2423160" y="5513832"/>
             <a:ext cx="45720" cy="146304"/>
           </a:xfrm>
           <a:prstGeom prst="rect">
@@ -18384,7 +18385,7 @@
         </p:nvSpPr>
         <p:spPr>
           <a:xfrm>
-            <a:off x="2350008" y="5577840"/>
+            <a:off x="2532888" y="5486400"/>
             <a:ext cx="5943600" cy="201168"/>
           </a:xfrm>
           <a:prstGeom prst="rect">
@@ -22867,6 +22868,24 @@
 </p:sld>
 </file>
 
+<file path=ppt/slides/slide21.xml><?xml version="1.0" encoding="utf-8"?>
+<p:sld xmlns:a="http://schemas.openxmlformats.org/drawingml/2006/main" xmlns:p="http://schemas.openxmlformats.org/presentationml/2006/main" xmlns:r="http://schemas.openxmlformats.org/officeDocument/2006/relationships">
+  <p:cSld>
+    <p:spTree>
+      <p:nvGrpSpPr>
+        <p:cNvPr id="1" name=""/>
+        <p:cNvGrpSpPr/>
+        <p:nvPr/>
+      </p:nvGrpSpPr>
+      <p:grpSpPr/>
+    </p:spTree>
+  </p:cSld>
+  <p:clrMapOvr>
+    <a:masterClrMapping/>
+  </p:clrMapOvr>
+</p:sld>
+</file>
+
 <file path=ppt/slides/slide3.xml><?xml version="1.0" encoding="utf-8"?>
 <p:sld xmlns:a="http://schemas.openxmlformats.org/drawingml/2006/main" xmlns:p="http://schemas.openxmlformats.org/presentationml/2006/main" xmlns:r="http://schemas.openxmlformats.org/officeDocument/2006/relationships">
   <p:cSld>
@@ -23609,12 +23628,12 @@
         </p:nvSpPr>
         <p:spPr>
           <a:xfrm>
-            <a:off x="5662739" y="4069079"/>
-            <a:ext cx="3478657" cy="364236"/>
+            <a:off x="5513958" y="4069079"/>
+            <a:ext cx="3776218" cy="339090"/>
           </a:xfrm>
           <a:prstGeom prst="roundRect">
             <a:avLst>
-              <a:gd name="adj" fmla="val 22594"/>
+              <a:gd name="adj" fmla="val 24269"/>
             </a:avLst>
           </a:prstGeom>
           <a:solidFill>
@@ -23647,7 +23666,7 @@
           <a:p>
             <a:pPr algn="ctr"/>
             <a:r>
-              <a:rPr sz="1300" b="0">
+              <a:rPr sz="1150" b="0">
                 <a:solidFill>
                   <a:srgbClr val="B5533C"/>
                 </a:solidFill>
@@ -23655,7 +23674,7 @@
                 <a:cs typeface="Readex Pro"/>
                 <a:ea typeface="Readex Pro"/>
               </a:rPr>
-              <a:t>not decoding · no reader claim yet</a:t>
+              <a:t>tashkeel is a setting · no reader claim yet</a:t>
             </a:r>
           </a:p>
         </p:txBody>

</xml_diff>

<commit_message>
Add the phone demo video and showcase it in the README
Ship the current recording in deliverables/05_demo/ and embed it in both
pitch decks beside the "What the app does" copy, with a README section
so reviewers can watch the flow. Swap in a longer capture later.
</commit_message>
<xml_diff>
--- a/deliverables/04_presentation/Bayan_Submission.pptx
+++ b/deliverables/04_presentation/Bayan_Submission.pptx
@@ -21039,55 +21039,18 @@
       </p:sp>
       <p:sp>
         <p:nvSpPr>
-          <p:cNvPr id="8" name="TextBox 7"/>
-          <p:cNvSpPr txBox="1"/>
-          <p:nvPr/>
-        </p:nvSpPr>
-        <p:spPr>
-          <a:xfrm>
-            <a:off x="566928" y="1600200"/>
-            <a:ext cx="8769096" cy="411480"/>
-          </a:xfrm>
-          <a:prstGeom prst="rect">
-            <a:avLst/>
-          </a:prstGeom>
-          <a:noFill/>
-        </p:spPr>
-        <p:txBody>
-          <a:bodyPr wrap="square" lIns="0" rIns="0" tIns="0" bIns="0" anchor="ctr">
-            <a:spAutoFit/>
-          </a:bodyPr>
-          <a:lstStyle/>
-          <a:p>
-            <a:pPr algn="ctr"/>
-            <a:r>
-              <a:rPr sz="2200" b="1">
-                <a:solidFill>
-                  <a:srgbClr val="282824"/>
-                </a:solidFill>
-                <a:latin typeface="Readex Pro"/>
-                <a:cs typeface="Readex Pro"/>
-                <a:ea typeface="Readex Pro"/>
-              </a:rPr>
-              <a:t>What the app does</a:t>
-            </a:r>
-          </a:p>
-        </p:txBody>
-      </p:sp>
-      <p:sp>
-        <p:nvSpPr>
-          <p:cNvPr id="9" name="Rounded Rectangle 8"/>
+          <p:cNvPr id="8" name="Rounded Rectangle 7"/>
           <p:cNvSpPr/>
           <p:nvPr/>
         </p:nvSpPr>
         <p:spPr>
           <a:xfrm>
-            <a:off x="3648456" y="2148840"/>
-            <a:ext cx="2606040" cy="3794760"/>
+            <a:off x="7034479" y="1481328"/>
+            <a:ext cx="2301544" cy="4846320"/>
           </a:xfrm>
           <a:prstGeom prst="roundRect">
             <a:avLst>
-              <a:gd name="adj" fmla="val 9122"/>
+              <a:gd name="adj" fmla="val 10329"/>
             </a:avLst>
           </a:prstGeom>
           <a:solidFill>
@@ -21122,62 +21085,49 @@
           </a:p>
         </p:txBody>
       </p:sp>
-      <p:sp>
-        <p:nvSpPr>
-          <p:cNvPr id="10" name="Rounded Rectangle 9"/>
-          <p:cNvSpPr/>
-          <p:nvPr/>
-        </p:nvSpPr>
-        <p:spPr>
-          <a:xfrm>
-            <a:off x="3758184" y="2258568"/>
-            <a:ext cx="2386584" cy="3575304"/>
-          </a:xfrm>
-          <a:prstGeom prst="roundRect">
-            <a:avLst>
-              <a:gd name="adj" fmla="val 6130"/>
-            </a:avLst>
-          </a:prstGeom>
-          <a:solidFill>
-            <a:srgbClr val="EFE9D9"/>
-          </a:solidFill>
-          <a:ln>
-            <a:noFill/>
-          </a:ln>
-          <a:effectLst/>
-        </p:spPr>
-        <p:style>
-          <a:lnRef idx="1">
-            <a:schemeClr val="accent1"/>
-          </a:lnRef>
-          <a:fillRef idx="3">
-            <a:schemeClr val="accent1"/>
-          </a:fillRef>
-          <a:effectRef idx="2">
-            <a:schemeClr val="accent1"/>
-          </a:effectRef>
-          <a:fontRef idx="minor">
-            <a:schemeClr val="lt1"/>
-          </a:fontRef>
-        </p:style>
-        <p:txBody>
-          <a:bodyPr rtlCol="0" anchor="ctr"/>
-          <a:lstStyle/>
-          <a:p>
-            <a:pPr algn="ctr"/>
-          </a:p>
-        </p:txBody>
-      </p:sp>
-      <p:sp>
-        <p:nvSpPr>
-          <p:cNvPr id="11" name="TextBox 10"/>
+      <p:pic>
+        <p:nvPicPr>
+          <p:cNvPr id="9" name="Demo video" descr="Bayan demo: select Arabic text, tap Simplify, read aloud">
+            <a:hlinkClick r:id="" action="ppaction://media"/>
+          </p:cNvPr>
+          <p:cNvPicPr>
+            <a:picLocks noChangeAspect="1"/>
+          </p:cNvPicPr>
+          <p:nvPr>
+            <a:videoFile r:link="rId4"/>
+            <p:extLst>
+              <p:ext uri="{DAA4B4D4-6D71-4841-9C94-3DE7FCFB9230}">
+                <p14:media xmlns:p14="http://schemas.microsoft.com/office/powerpoint/2010/main" r:embed="rId3"/>
+              </p:ext>
+            </p:extLst>
+          </p:nvPr>
+        </p:nvPicPr>
+        <p:blipFill>
+          <a:blip r:embed="rId5"/>
+          <a:stretch>
+            <a:fillRect/>
+          </a:stretch>
+        </p:blipFill>
+        <p:spPr>
+          <a:xfrm>
+            <a:off x="7144207" y="1591056"/>
+            <a:ext cx="2082088" cy="4626864"/>
+          </a:xfrm>
+          <a:prstGeom prst="rect">
+            <a:avLst/>
+          </a:prstGeom>
+        </p:spPr>
+      </p:pic>
+      <p:sp>
+        <p:nvSpPr>
+          <p:cNvPr id="10" name="TextBox 9"/>
           <p:cNvSpPr txBox="1"/>
           <p:nvPr/>
         </p:nvSpPr>
         <p:spPr>
           <a:xfrm>
-            <a:off x="3648456" y="3543300"/>
-            <a:ext cx="2606040" cy="777240"/>
+            <a:off x="566928" y="2468880"/>
+            <a:ext cx="6010351" cy="502920"/>
           </a:xfrm>
           <a:prstGeom prst="rect">
             <a:avLst/>
@@ -21190,31 +21140,31 @@
           </a:bodyPr>
           <a:lstStyle/>
           <a:p>
-            <a:pPr algn="ctr"/>
-            <a:r>
-              <a:rPr sz="3600" b="0">
-                <a:solidFill>
-                  <a:srgbClr val="6F6B5E"/>
-                </a:solidFill>
-                <a:latin typeface="Readex Pro"/>
-                <a:cs typeface="Readex Pro"/>
-                <a:ea typeface="Readex Pro"/>
-              </a:rPr>
-              <a:t>▶</a:t>
-            </a:r>
-          </a:p>
-        </p:txBody>
-      </p:sp>
-      <p:sp>
-        <p:nvSpPr>
-          <p:cNvPr id="12" name="TextBox 11"/>
+            <a:pPr algn="l"/>
+            <a:r>
+              <a:rPr sz="3000" b="1">
+                <a:solidFill>
+                  <a:srgbClr val="282824"/>
+                </a:solidFill>
+                <a:latin typeface="Readex Pro"/>
+                <a:cs typeface="Readex Pro"/>
+                <a:ea typeface="Readex Pro"/>
+              </a:rPr>
+              <a:t>What the app does</a:t>
+            </a:r>
+          </a:p>
+        </p:txBody>
+      </p:sp>
+      <p:sp>
+        <p:nvSpPr>
+          <p:cNvPr id="11" name="TextBox 10"/>
           <p:cNvSpPr txBox="1"/>
           <p:nvPr/>
         </p:nvSpPr>
         <p:spPr>
           <a:xfrm>
-            <a:off x="3648456" y="4457700"/>
-            <a:ext cx="2606040" cy="274320"/>
+            <a:off x="566928" y="3154680"/>
+            <a:ext cx="6010351" cy="1463040"/>
           </a:xfrm>
           <a:prstGeom prst="rect">
             <a:avLst/>
@@ -21227,17 +21177,57 @@
           </a:bodyPr>
           <a:lstStyle/>
           <a:p>
-            <a:pPr algn="ctr"/>
-            <a:r>
-              <a:rPr sz="1200" b="0">
-                <a:solidFill>
-                  <a:srgbClr val="6F6B5E"/>
-                </a:solidFill>
-                <a:latin typeface="Readex Pro"/>
-                <a:cs typeface="Readex Pro"/>
-                <a:ea typeface="Readex Pro"/>
-              </a:rPr>
-              <a:t>recording goes here</a:t>
+            <a:pPr algn="l">
+              <a:lnSpc>
+                <a:spcPct val="125000"/>
+              </a:lnSpc>
+            </a:pPr>
+            <a:r>
+              <a:rPr sz="1800" b="0">
+                <a:solidFill>
+                  <a:srgbClr val="4A4842"/>
+                </a:solidFill>
+                <a:latin typeface="Readex Pro"/>
+                <a:cs typeface="Readex Pro"/>
+                <a:ea typeface="Readex Pro"/>
+              </a:rPr>
+              <a:t>Select Arabic text in any app.</a:t>
+            </a:r>
+          </a:p>
+          <a:p>
+            <a:pPr algn="l">
+              <a:lnSpc>
+                <a:spcPct val="125000"/>
+              </a:lnSpc>
+            </a:pPr>
+            <a:r>
+              <a:rPr sz="1800" b="0">
+                <a:solidFill>
+                  <a:srgbClr val="4A4842"/>
+                </a:solidFill>
+                <a:latin typeface="Readex Pro"/>
+                <a:cs typeface="Readex Pro"/>
+                <a:ea typeface="Readex Pro"/>
+              </a:rPr>
+              <a:t>Tap تبسيط. Bayan simplifies it</a:t>
+            </a:r>
+          </a:p>
+          <a:p>
+            <a:pPr algn="l">
+              <a:lnSpc>
+                <a:spcPct val="125000"/>
+              </a:lnSpc>
+            </a:pPr>
+            <a:r>
+              <a:rPr sz="1800" b="0">
+                <a:solidFill>
+                  <a:srgbClr val="4A4842"/>
+                </a:solidFill>
+                <a:latin typeface="Readex Pro"/>
+                <a:cs typeface="Readex Pro"/>
+                <a:ea typeface="Readex Pro"/>
+              </a:rPr>
+              <a:t>and reads it aloud.</a:t>
             </a:r>
           </a:p>
         </p:txBody>
@@ -21247,6 +21237,50 @@
   <p:clrMapOvr>
     <a:masterClrMapping/>
   </p:clrMapOvr>
+  <p:timing>
+    <p:tnLst>
+      <p:par>
+        <p:cTn id="1" dur="indefinite" restart="never" nodeType="tmRoot">
+          <p:childTnLst>
+            <p:video>
+              <p:cMediaNode vol="80000">
+                <p:cTn id="2" fill="hold" display="0">
+                  <p:stCondLst>
+                    <p:cond delay="indefinite"/>
+                  </p:stCondLst>
+                </p:cTn>
+                <p:tgtEl>
+                  <p:spTgt spid="9"/>
+                </p:tgtEl>
+              </p:cMediaNode>
+            </p:video>
+          </p:childTnLst>
+        </p:cTn>
+      </p:par>
+    </p:tnLst>
+  </p:timing>
+  <p:timing>
+    <p:tnLst>
+      <p:par>
+        <p:cTn id="1" dur="indefinite" restart="never" nodeType="tmRoot">
+          <p:childTnLst>
+            <p:video>
+              <p:cMediaNode vol="80000">
+                <p:cTn id="2" fill="hold" display="0">
+                  <p:stCondLst>
+                    <p:cond delay="0"/>
+                  </p:stCondLst>
+                </p:cTn>
+                <p:tgtEl>
+                  <p:spTgt spid="9"/>
+                </p:tgtEl>
+              </p:cMediaNode>
+            </p:video>
+          </p:childTnLst>
+        </p:cTn>
+      </p:par>
+    </p:tnLst>
+  </p:timing>
 </p:sld>
 </file>
 

</xml_diff>

<commit_message>
Submission deck: use the new demo (status bar cropped)
Swap the deck demo assets for the new clip, fix the phone-frame aspect
ratio to 1080x2316, and rebuild Bayan_Submission.pptx.

Co-Authored-By: Claude Sonnet 5.5 <noreply@anthropic.com>
Claude-Session: https://claude.ai/code/session_01MJtnn7136C65w1hgrT9tgE
</commit_message>
<xml_diff>
--- a/deliverables/04_presentation/Bayan_Submission.pptx
+++ b/deliverables/04_presentation/Bayan_Submission.pptx
@@ -21045,12 +21045,12 @@
         </p:nvSpPr>
         <p:spPr>
           <a:xfrm>
-            <a:off x="7034479" y="1481328"/>
-            <a:ext cx="2301544" cy="4846320"/>
+            <a:off x="6958963" y="1481328"/>
+            <a:ext cx="2377060" cy="4846320"/>
           </a:xfrm>
           <a:prstGeom prst="roundRect">
             <a:avLst>
-              <a:gd name="adj" fmla="val 10329"/>
+              <a:gd name="adj" fmla="val 10001"/>
             </a:avLst>
           </a:prstGeom>
           <a:solidFill>
@@ -21110,8 +21110,8 @@
         </p:blipFill>
         <p:spPr>
           <a:xfrm>
-            <a:off x="7144207" y="1591056"/>
-            <a:ext cx="2082088" cy="4626864"/>
+            <a:off x="7068691" y="1591056"/>
+            <a:ext cx="2157604" cy="4626864"/>
           </a:xfrm>
           <a:prstGeom prst="rect">
             <a:avLst/>
@@ -21127,7 +21127,7 @@
         <p:spPr>
           <a:xfrm>
             <a:off x="566928" y="2468880"/>
-            <a:ext cx="6010351" cy="502920"/>
+            <a:ext cx="5934835" cy="502920"/>
           </a:xfrm>
           <a:prstGeom prst="rect">
             <a:avLst/>
@@ -21164,7 +21164,7 @@
         <p:spPr>
           <a:xfrm>
             <a:off x="566928" y="3154680"/>
-            <a:ext cx="6010351" cy="1463040"/>
+            <a:ext cx="5934835" cy="1463040"/>
           </a:xfrm>
           <a:prstGeom prst="rect">
             <a:avLst/>

</xml_diff>

<commit_message>
Presentation: phone bezel, correct slide totals, change-aware scene rendering
- S7Phone plays assets/demo_bezel.mp4: the recording in a rounded Android bezel
  (80% of slide height, centered, drop shadow) on the deck beige, built by build_bezel.py (#82 part B).
- Slide counters read N / 10 (was N / 9 with a 10th scene); submission deck N / 9 (was N / 8).
- render_videos.sh now renders only scenes whose class source or shared inputs changed
  (render_changed.py); --force re-renders everything.
- README scene counts updated; deliverables rebuilt.

Refs #82

Co-Authored-By: Claude Sonnet 5.5 <noreply@anthropic.com>
</commit_message>
<xml_diff>
--- a/deliverables/04_presentation/Bayan_Submission.pptx
+++ b/deliverables/04_presentation/Bayan_Submission.pptx
@@ -11271,7 +11271,7 @@
                 <a:cs typeface="Readex Pro"/>
                 <a:ea typeface="Readex Pro"/>
               </a:rPr>
-              <a:t>1 / 8</a:t>
+              <a:t>1 / 9</a:t>
             </a:r>
           </a:p>
         </p:txBody>
@@ -11758,7 +11758,7 @@
                 <a:cs typeface="Readex Pro"/>
                 <a:ea typeface="Readex Pro"/>
               </a:rPr>
-              <a:t>5 / 8</a:t>
+              <a:t>5 / 9</a:t>
             </a:r>
           </a:p>
         </p:txBody>
@@ -12330,7 +12330,7 @@
                 <a:cs typeface="Readex Pro"/>
                 <a:ea typeface="Readex Pro"/>
               </a:rPr>
-              <a:t>5 / 8</a:t>
+              <a:t>5 / 9</a:t>
             </a:r>
           </a:p>
         </p:txBody>
@@ -13232,7 +13232,7 @@
                 <a:cs typeface="Readex Pro"/>
                 <a:ea typeface="Readex Pro"/>
               </a:rPr>
-              <a:t>5 / 8</a:t>
+              <a:t>5 / 9</a:t>
             </a:r>
           </a:p>
         </p:txBody>
@@ -14678,7 +14678,7 @@
                 <a:cs typeface="Readex Pro"/>
                 <a:ea typeface="Readex Pro"/>
               </a:rPr>
-              <a:t>6 / 8</a:t>
+              <a:t>6 / 9</a:t>
             </a:r>
           </a:p>
         </p:txBody>
@@ -16117,7 +16117,7 @@
                 <a:cs typeface="Readex Pro"/>
                 <a:ea typeface="Readex Pro"/>
               </a:rPr>
-              <a:t>6 / 8</a:t>
+              <a:t>6 / 9</a:t>
             </a:r>
           </a:p>
         </p:txBody>
@@ -17327,7 +17327,7 @@
                 <a:cs typeface="Readex Pro"/>
                 <a:ea typeface="Readex Pro"/>
               </a:rPr>
-              <a:t>6 / 8</a:t>
+              <a:t>6 / 9</a:t>
             </a:r>
           </a:p>
         </p:txBody>
@@ -18199,7 +18199,7 @@
                 <a:cs typeface="Readex Pro"/>
                 <a:ea typeface="Readex Pro"/>
               </a:rPr>
-              <a:t>6 / 8</a:t>
+              <a:t>6 / 9</a:t>
             </a:r>
           </a:p>
         </p:txBody>
@@ -19152,7 +19152,7 @@
                 <a:cs typeface="Readex Pro"/>
                 <a:ea typeface="Readex Pro"/>
               </a:rPr>
-              <a:t>7 / 8</a:t>
+              <a:t>7 / 9</a:t>
             </a:r>
           </a:p>
         </p:txBody>
@@ -20580,7 +20580,7 @@
                 <a:cs typeface="Readex Pro"/>
                 <a:ea typeface="Readex Pro"/>
               </a:rPr>
-              <a:t>7 / 8</a:t>
+              <a:t>7 / 9</a:t>
             </a:r>
           </a:p>
         </p:txBody>
@@ -21846,7 +21846,7 @@
                 <a:cs typeface="Readex Pro"/>
                 <a:ea typeface="Readex Pro"/>
               </a:rPr>
-              <a:t>7 / 8</a:t>
+              <a:t>7 / 9</a:t>
             </a:r>
           </a:p>
         </p:txBody>
@@ -22729,7 +22729,7 @@
                 <a:cs typeface="Readex Pro"/>
                 <a:ea typeface="Readex Pro"/>
               </a:rPr>
-              <a:t>2 / 8</a:t>
+              <a:t>2 / 9</a:t>
             </a:r>
           </a:p>
         </p:txBody>
@@ -23641,7 +23641,7 @@
                 <a:cs typeface="Readex Pro"/>
                 <a:ea typeface="Readex Pro"/>
               </a:rPr>
-              <a:t>8 / 8</a:t>
+              <a:t>8 / 9</a:t>
             </a:r>
           </a:p>
         </p:txBody>
@@ -24040,7 +24040,7 @@
                 <a:cs typeface="Readex Pro"/>
                 <a:ea typeface="Readex Pro"/>
               </a:rPr>
-              <a:t>9 / 8</a:t>
+              <a:t>9 / 9</a:t>
             </a:r>
           </a:p>
         </p:txBody>
@@ -24261,7 +24261,7 @@
                 <a:cs typeface="Readex Pro"/>
                 <a:ea typeface="Readex Pro"/>
               </a:rPr>
-              <a:t>9 / 8</a:t>
+              <a:t>9 / 9</a:t>
             </a:r>
           </a:p>
         </p:txBody>
@@ -24845,7 +24845,7 @@
                 <a:cs typeface="Readex Pro"/>
                 <a:ea typeface="Readex Pro"/>
               </a:rPr>
-              <a:t>2 / 8</a:t>
+              <a:t>2 / 9</a:t>
             </a:r>
           </a:p>
         </p:txBody>
@@ -25646,7 +25646,7 @@
                 <a:cs typeface="Readex Pro"/>
                 <a:ea typeface="Readex Pro"/>
               </a:rPr>
-              <a:t>3 / 8</a:t>
+              <a:t>3 / 9</a:t>
             </a:r>
           </a:p>
         </p:txBody>
@@ -26448,7 +26448,7 @@
                 <a:cs typeface="Readex Pro"/>
                 <a:ea typeface="Readex Pro"/>
               </a:rPr>
-              <a:t>3 / 8</a:t>
+              <a:t>3 / 9</a:t>
             </a:r>
           </a:p>
         </p:txBody>
@@ -27327,7 +27327,7 @@
                 <a:cs typeface="Readex Pro"/>
                 <a:ea typeface="Readex Pro"/>
               </a:rPr>
-              <a:t>3 / 8</a:t>
+              <a:t>3 / 9</a:t>
             </a:r>
           </a:p>
         </p:txBody>
@@ -28555,7 +28555,7 @@
                 <a:cs typeface="Readex Pro"/>
                 <a:ea typeface="Readex Pro"/>
               </a:rPr>
-              <a:t>3 / 8</a:t>
+              <a:t>3 / 9</a:t>
             </a:r>
           </a:p>
         </p:txBody>
@@ -29124,7 +29124,7 @@
                 <a:cs typeface="Readex Pro"/>
                 <a:ea typeface="Readex Pro"/>
               </a:rPr>
-              <a:t>4 / 8</a:t>
+              <a:t>4 / 9</a:t>
             </a:r>
           </a:p>
         </p:txBody>
@@ -30266,7 +30266,7 @@
                 <a:cs typeface="Readex Pro"/>
                 <a:ea typeface="Readex Pro"/>
               </a:rPr>
-              <a:t>4 / 8</a:t>
+              <a:t>4 / 9</a:t>
             </a:r>
           </a:p>
         </p:txBody>

</xml_diff>